<commit_message>
Agrega diapositiva: Cómo incorporarlo a nuestro Reglamento Interno (I.E.S. JEC Rosaspata)
</commit_message>
<xml_diff>
--- a/Grupo_Natalio_Articulos_9_13.pptx
+++ b/Grupo_Natalio_Articulos_9_13.pptx
@@ -13,6 +13,7 @@
     <p:sldId id="261" r:id="rId13"/>
     <p:sldId id="262" r:id="rId14"/>
     <p:sldId id="263" r:id="rId15"/>
+    <p:sldId id="264" r:id="rId16"/>
   </p:sldIdLst>
   <p:sldSz cx="12191695" cy="6858000" type="screen4x3"/>
   <p:notesSz cx="6858000" cy="9144000"/>
@@ -955,6 +956,76 @@
 </file>
 
 <file path=ppt/notesSlides/notesSlide8.xml><?xml version="1.0" encoding="utf-8"?>
+<p:notes xmlns:a="http://schemas.openxmlformats.org/drawingml/2006/main" xmlns:p="http://schemas.openxmlformats.org/presentationml/2006/main" xmlns:r="http://schemas.openxmlformats.org/officeDocument/2006/relationships">
+  <p:cSld>
+    <p:spTree>
+      <p:nvGrpSpPr>
+        <p:cNvPr id="1" name=""/>
+        <p:cNvGrpSpPr/>
+        <p:nvPr/>
+      </p:nvGrpSpPr>
+      <p:grpSpPr>
+        <a:xfrm>
+          <a:off x="0" y="0"/>
+          <a:ext cx="0" cy="0"/>
+          <a:chOff x="0" y="0"/>
+          <a:chExt cx="0" cy="0"/>
+        </a:xfrm>
+      </p:grpSpPr>
+      <p:sp>
+        <p:nvSpPr>
+          <p:cNvPr id="2" name="Slide Image Placeholder 1"/>
+          <p:cNvSpPr>
+            <a:spLocks noGrp="1"/>
+          </p:cNvSpPr>
+          <p:nvPr>
+            <p:ph type="sldImg" idx="2"/>
+          </p:nvPr>
+        </p:nvSpPr>
+        <p:spPr/>
+      </p:sp>
+      <p:sp>
+        <p:nvSpPr>
+          <p:cNvPr id="3" name="Notes Placeholder 2"/>
+          <p:cNvSpPr>
+            <a:spLocks noGrp="1"/>
+          </p:cNvSpPr>
+          <p:nvPr>
+            <p:ph type="body" idx="3" sz="quarter"/>
+          </p:nvPr>
+        </p:nvSpPr>
+        <p:spPr/>
+        <p:txBody>
+          <a:bodyPr/>
+          <a:lstStyle/>
+          <a:p>
+            <a:r>
+              <a:t>Fuente: Reglamento de la Ley N.º 32385, aprobado por Decreto Supremo N.º 018-2026-MINEDU, Diario Oficial El Peruano, Normas Legales, 3 de octubre de 2026, pp. 13-16. Reglamento Interno 2026 de la I.E.S. Jornada Escolar Completa “Rosaspata” (Rosaspata, Huancané, Puno), aprobado por R.D. N.º 012-2026-DIR-IES “R”/R. Propuestas: (1) Nuevo artículo sobre uso del celular en clase, actualizando la norma de convivencia 8 del Art. 134° y el deber 18 del Art. 136° (Tít. V, Cap. I). (2) Art. 9 → incluir el uso seguro y responsable del celular entre los programas de TOE del Art. 103° (Tít. IV, Cap. IV, Tutoría). (3) Arts. 10 y 13 → ampliar el Art. 152° (Tít. V, Cap. VI, De los Padres de Familia) con orientación a familias y compromisos de uso responsable en casa. (4) Art. 11 → en el Tít. III, Cap. X (Clima escolar), Art. 69° (SISEVE y cuaderno de incidencias): monitoreo con respeto a la dignidad, sin revisar el contenido de los celulares; ciberacoso según D.S. N.º 004-2018-MINEDU. (5) Art. 12 → revisar las faltas y medidas de los Arts. 141°–145° (falta leve 11, falta grave 17) para que sean claras, oportunas, reparadoras, formativas, razonables, proporcionales y graduales, informando a la familia.</a:t>
+            </a:r>
+          </a:p>
+        </p:txBody>
+      </p:sp>
+      <p:sp>
+        <p:nvSpPr>
+          <p:cNvPr id="4" name="Slide Number Placeholder 3"/>
+          <p:cNvSpPr>
+            <a:spLocks noGrp="1"/>
+          </p:cNvSpPr>
+          <p:nvPr>
+            <p:ph type="sldNum" idx="5" sz="quarter"/>
+          </p:nvPr>
+        </p:nvSpPr>
+        <p:spPr/>
+      </p:sp>
+    </p:spTree>
+  </p:cSld>
+  <p:clrMapOvr>
+    <a:masterClrMapping/>
+  </p:clrMapOvr>
+</p:notes>
+</file>
+
+<file path=ppt/notesSlides/notesSlide9.xml><?xml version="1.0" encoding="utf-8"?>
 <p:notes xmlns:a="http://schemas.openxmlformats.org/drawingml/2006/main" xmlns:p="http://schemas.openxmlformats.org/presentationml/2006/main" xmlns:r="http://schemas.openxmlformats.org/officeDocument/2006/relationships">
   <p:cSld>
     <p:spTree>
@@ -12504,6 +12575,2568 @@
 </file>
 
 <file path=ppt/slides/slide8.xml><?xml version="1.0" encoding="utf-8"?>
+<p:sld xmlns:a="http://schemas.openxmlformats.org/drawingml/2006/main" xmlns:p="http://schemas.openxmlformats.org/presentationml/2006/main" xmlns:r="http://schemas.openxmlformats.org/officeDocument/2006/relationships">
+  <p:cSld>
+    <p:spTree>
+      <p:nvGrpSpPr>
+        <p:cNvPr id="1" name=""/>
+        <p:cNvGrpSpPr/>
+        <p:nvPr/>
+      </p:nvGrpSpPr>
+      <p:grpSpPr/>
+      <p:sp>
+        <p:nvSpPr>
+          <p:cNvPr id="2" name="Rectangle 1"/>
+          <p:cNvSpPr/>
+          <p:nvPr/>
+        </p:nvSpPr>
+        <p:spPr>
+          <a:xfrm>
+            <a:off x="0" y="0"/>
+            <a:ext cx="12191695" cy="6858000"/>
+          </a:xfrm>
+          <a:prstGeom prst="rect">
+            <a:avLst/>
+          </a:prstGeom>
+          <a:solidFill>
+            <a:srgbClr val="F6F3EE"/>
+          </a:solidFill>
+          <a:ln>
+            <a:noFill/>
+          </a:ln>
+          <a:effectLst/>
+        </p:spPr>
+        <p:style>
+          <a:lnRef idx="1">
+            <a:schemeClr val="accent1"/>
+          </a:lnRef>
+          <a:fillRef idx="3">
+            <a:schemeClr val="accent1"/>
+          </a:fillRef>
+          <a:effectRef idx="2">
+            <a:schemeClr val="accent1"/>
+          </a:effectRef>
+          <a:fontRef idx="minor">
+            <a:schemeClr val="lt1"/>
+          </a:fontRef>
+        </p:style>
+        <p:txBody>
+          <a:bodyPr rtlCol="0" anchor="ctr"/>
+          <a:lstStyle/>
+          <a:p>
+            <a:pPr algn="ctr"/>
+          </a:p>
+        </p:txBody>
+      </p:sp>
+      <p:sp>
+        <p:nvSpPr>
+          <p:cNvPr id="3" name="TextBox 2"/>
+          <p:cNvSpPr txBox="1"/>
+          <p:nvPr/>
+        </p:nvSpPr>
+        <p:spPr>
+          <a:xfrm>
+            <a:off x="731520" y="457200"/>
+            <a:ext cx="10789920" cy="365760"/>
+          </a:xfrm>
+          <a:prstGeom prst="rect">
+            <a:avLst/>
+          </a:prstGeom>
+          <a:noFill/>
+        </p:spPr>
+        <p:txBody>
+          <a:bodyPr wrap="square" anchor="t" lIns="0" rIns="0" tIns="0" bIns="0">
+            <a:spAutoFit/>
+          </a:bodyPr>
+          <a:lstStyle/>
+          <a:p>
+            <a:pPr algn="l"/>
+            <a:r>
+              <a:rPr sz="1400" b="1">
+                <a:solidFill>
+                  <a:srgbClr val="0E7C7B"/>
+                </a:solidFill>
+                <a:latin typeface="Poppins"/>
+              </a:rPr>
+              <a:t>PROPUESTA  ·  REGLAMENTO INTERNO 2026 DE LA I.E.S. JEC “ROSASPATA”</a:t>
+            </a:r>
+          </a:p>
+        </p:txBody>
+      </p:sp>
+      <p:sp>
+        <p:nvSpPr>
+          <p:cNvPr id="4" name="TextBox 3"/>
+          <p:cNvSpPr txBox="1"/>
+          <p:nvPr/>
+        </p:nvSpPr>
+        <p:spPr>
+          <a:xfrm>
+            <a:off x="731520" y="822960"/>
+            <a:ext cx="10789920" cy="731520"/>
+          </a:xfrm>
+          <a:prstGeom prst="rect">
+            <a:avLst/>
+          </a:prstGeom>
+          <a:noFill/>
+        </p:spPr>
+        <p:txBody>
+          <a:bodyPr wrap="square" anchor="t" lIns="0" rIns="0" tIns="0" bIns="0">
+            <a:spAutoFit/>
+          </a:bodyPr>
+          <a:lstStyle/>
+          <a:p>
+            <a:pPr algn="l"/>
+            <a:r>
+              <a:rPr sz="3200" b="1">
+                <a:solidFill>
+                  <a:srgbClr val="0F2A44"/>
+                </a:solidFill>
+                <a:latin typeface="Poppins"/>
+              </a:rPr>
+              <a:t>Cómo incorporarlo a nuestro Reglamento Interno</a:t>
+            </a:r>
+          </a:p>
+        </p:txBody>
+      </p:sp>
+      <p:sp>
+        <p:nvSpPr>
+          <p:cNvPr id="5" name="Rounded Rectangle 4"/>
+          <p:cNvSpPr/>
+          <p:nvPr/>
+        </p:nvSpPr>
+        <p:spPr>
+          <a:xfrm>
+            <a:off x="731520" y="1828800"/>
+            <a:ext cx="2002536" cy="4343400"/>
+          </a:xfrm>
+          <a:prstGeom prst="roundRect">
+            <a:avLst>
+              <a:gd name="adj" fmla="val 7000"/>
+            </a:avLst>
+          </a:prstGeom>
+          <a:solidFill>
+            <a:srgbClr val="FFFFFF"/>
+          </a:solidFill>
+          <a:ln>
+            <a:noFill/>
+          </a:ln>
+          <a:effectLst/>
+        </p:spPr>
+        <p:style>
+          <a:lnRef idx="1">
+            <a:schemeClr val="accent1"/>
+          </a:lnRef>
+          <a:fillRef idx="3">
+            <a:schemeClr val="accent1"/>
+          </a:fillRef>
+          <a:effectRef idx="2">
+            <a:schemeClr val="accent1"/>
+          </a:effectRef>
+          <a:fontRef idx="minor">
+            <a:schemeClr val="lt1"/>
+          </a:fontRef>
+        </p:style>
+        <p:txBody>
+          <a:bodyPr rtlCol="0" anchor="ctr"/>
+          <a:lstStyle/>
+          <a:p>
+            <a:pPr algn="ctr"/>
+          </a:p>
+        </p:txBody>
+      </p:sp>
+      <p:sp>
+        <p:nvSpPr>
+          <p:cNvPr id="6" name="Rounded Rectangle 5"/>
+          <p:cNvSpPr/>
+          <p:nvPr/>
+        </p:nvSpPr>
+        <p:spPr>
+          <a:xfrm>
+            <a:off x="731520" y="1828800"/>
+            <a:ext cx="2002536" cy="1325880"/>
+          </a:xfrm>
+          <a:prstGeom prst="roundRect">
+            <a:avLst>
+              <a:gd name="adj" fmla="val 16000"/>
+            </a:avLst>
+          </a:prstGeom>
+          <a:solidFill>
+            <a:srgbClr val="E0A526"/>
+          </a:solidFill>
+          <a:ln>
+            <a:noFill/>
+          </a:ln>
+          <a:effectLst/>
+        </p:spPr>
+        <p:style>
+          <a:lnRef idx="1">
+            <a:schemeClr val="accent1"/>
+          </a:lnRef>
+          <a:fillRef idx="3">
+            <a:schemeClr val="accent1"/>
+          </a:fillRef>
+          <a:effectRef idx="2">
+            <a:schemeClr val="accent1"/>
+          </a:effectRef>
+          <a:fontRef idx="minor">
+            <a:schemeClr val="lt1"/>
+          </a:fontRef>
+        </p:style>
+        <p:txBody>
+          <a:bodyPr rtlCol="0" anchor="ctr"/>
+          <a:lstStyle/>
+          <a:p>
+            <a:pPr algn="ctr"/>
+          </a:p>
+        </p:txBody>
+      </p:sp>
+      <p:sp>
+        <p:nvSpPr>
+          <p:cNvPr id="7" name="Rectangle 6"/>
+          <p:cNvSpPr/>
+          <p:nvPr/>
+        </p:nvSpPr>
+        <p:spPr>
+          <a:xfrm>
+            <a:off x="731520" y="2788920"/>
+            <a:ext cx="2002536" cy="365760"/>
+          </a:xfrm>
+          <a:prstGeom prst="rect">
+            <a:avLst/>
+          </a:prstGeom>
+          <a:solidFill>
+            <a:srgbClr val="E0A526"/>
+          </a:solidFill>
+          <a:ln>
+            <a:noFill/>
+          </a:ln>
+          <a:effectLst/>
+        </p:spPr>
+        <p:style>
+          <a:lnRef idx="1">
+            <a:schemeClr val="accent1"/>
+          </a:lnRef>
+          <a:fillRef idx="3">
+            <a:schemeClr val="accent1"/>
+          </a:fillRef>
+          <a:effectRef idx="2">
+            <a:schemeClr val="accent1"/>
+          </a:effectRef>
+          <a:fontRef idx="minor">
+            <a:schemeClr val="lt1"/>
+          </a:fontRef>
+        </p:style>
+        <p:txBody>
+          <a:bodyPr rtlCol="0" anchor="ctr"/>
+          <a:lstStyle/>
+          <a:p>
+            <a:pPr algn="ctr"/>
+          </a:p>
+        </p:txBody>
+      </p:sp>
+      <p:sp>
+        <p:nvSpPr>
+          <p:cNvPr id="8" name="Oval 7"/>
+          <p:cNvSpPr/>
+          <p:nvPr/>
+        </p:nvSpPr>
+        <p:spPr>
+          <a:xfrm>
+            <a:off x="1376172" y="1993392"/>
+            <a:ext cx="713232" cy="713232"/>
+          </a:xfrm>
+          <a:prstGeom prst="ellipse">
+            <a:avLst/>
+          </a:prstGeom>
+          <a:solidFill>
+            <a:srgbClr val="FFFFFF">
+              <a:alpha val="22000"/>
+            </a:srgbClr>
+          </a:solidFill>
+          <a:ln>
+            <a:noFill/>
+          </a:ln>
+          <a:effectLst/>
+        </p:spPr>
+        <p:style>
+          <a:lnRef idx="1">
+            <a:schemeClr val="accent1"/>
+          </a:lnRef>
+          <a:fillRef idx="3">
+            <a:schemeClr val="accent1"/>
+          </a:fillRef>
+          <a:effectRef idx="2">
+            <a:schemeClr val="accent1"/>
+          </a:effectRef>
+          <a:fontRef idx="minor">
+            <a:schemeClr val="lt1"/>
+          </a:fontRef>
+        </p:style>
+        <p:txBody>
+          <a:bodyPr rtlCol="0" anchor="ctr"/>
+          <a:lstStyle/>
+          <a:p>
+            <a:pPr algn="ctr"/>
+          </a:p>
+        </p:txBody>
+      </p:sp>
+      <p:pic>
+        <p:nvPicPr>
+          <p:cNvPr id="9" name="Picture 8" descr="f10b_0F2A44.png"/>
+          <p:cNvPicPr>
+            <a:picLocks noChangeAspect="1"/>
+          </p:cNvPicPr>
+          <p:nvPr/>
+        </p:nvPicPr>
+        <p:blipFill>
+          <a:blip r:embed="rId2"/>
+          <a:stretch>
+            <a:fillRect/>
+          </a:stretch>
+        </p:blipFill>
+        <p:spPr>
+          <a:xfrm>
+            <a:off x="1513332" y="2130552"/>
+            <a:ext cx="438912" cy="438912"/>
+          </a:xfrm>
+          <a:prstGeom prst="rect">
+            <a:avLst/>
+          </a:prstGeom>
+        </p:spPr>
+      </p:pic>
+      <p:sp>
+        <p:nvSpPr>
+          <p:cNvPr id="10" name="TextBox 9"/>
+          <p:cNvSpPr txBox="1"/>
+          <p:nvPr/>
+        </p:nvSpPr>
+        <p:spPr>
+          <a:xfrm>
+            <a:off x="822960" y="2743200"/>
+            <a:ext cx="1819656" cy="365760"/>
+          </a:xfrm>
+          <a:prstGeom prst="rect">
+            <a:avLst/>
+          </a:prstGeom>
+          <a:noFill/>
+        </p:spPr>
+        <p:txBody>
+          <a:bodyPr wrap="square" anchor="ctr" lIns="0" rIns="0" tIns="0" bIns="0">
+            <a:spAutoFit/>
+          </a:bodyPr>
+          <a:lstStyle/>
+          <a:p>
+            <a:pPr algn="ctr"/>
+            <a:r>
+              <a:rPr sz="1600" b="1">
+                <a:solidFill>
+                  <a:srgbClr val="0F2A44"/>
+                </a:solidFill>
+                <a:latin typeface="Poppins"/>
+              </a:rPr>
+              <a:t>Ley 32385</a:t>
+            </a:r>
+          </a:p>
+        </p:txBody>
+      </p:sp>
+      <p:sp>
+        <p:nvSpPr>
+          <p:cNvPr id="11" name="TextBox 10"/>
+          <p:cNvSpPr txBox="1"/>
+          <p:nvPr/>
+        </p:nvSpPr>
+        <p:spPr>
+          <a:xfrm>
+            <a:off x="914400" y="3337560"/>
+            <a:ext cx="1636776" cy="960120"/>
+          </a:xfrm>
+          <a:prstGeom prst="rect">
+            <a:avLst/>
+          </a:prstGeom>
+          <a:noFill/>
+        </p:spPr>
+        <p:txBody>
+          <a:bodyPr wrap="square" anchor="ctr" lIns="0" rIns="0" tIns="0" bIns="0">
+            <a:spAutoFit/>
+          </a:bodyPr>
+          <a:lstStyle/>
+          <a:p>
+            <a:pPr algn="ctr">
+              <a:lnSpc>
+                <a:spcPct val="100000"/>
+              </a:lnSpc>
+            </a:pPr>
+            <a:r>
+              <a:rPr sz="1600" b="1">
+                <a:solidFill>
+                  <a:srgbClr val="0F2A44"/>
+                </a:solidFill>
+                <a:latin typeface="Poppins"/>
+              </a:rPr>
+              <a:t>Nuevo artículo: celular en clase</a:t>
+            </a:r>
+          </a:p>
+        </p:txBody>
+      </p:sp>
+      <p:sp>
+        <p:nvSpPr>
+          <p:cNvPr id="12" name="Down Arrow 11"/>
+          <p:cNvSpPr/>
+          <p:nvPr/>
+        </p:nvSpPr>
+        <p:spPr>
+          <a:xfrm>
+            <a:off x="1540764" y="4407408"/>
+            <a:ext cx="384048" cy="274320"/>
+          </a:xfrm>
+          <a:prstGeom prst="downArrow">
+            <a:avLst/>
+          </a:prstGeom>
+          <a:solidFill>
+            <a:srgbClr val="E0A526"/>
+          </a:solidFill>
+          <a:ln>
+            <a:noFill/>
+          </a:ln>
+          <a:effectLst/>
+        </p:spPr>
+        <p:style>
+          <a:lnRef idx="1">
+            <a:schemeClr val="accent1"/>
+          </a:lnRef>
+          <a:fillRef idx="3">
+            <a:schemeClr val="accent1"/>
+          </a:fillRef>
+          <a:effectRef idx="2">
+            <a:schemeClr val="accent1"/>
+          </a:effectRef>
+          <a:fontRef idx="minor">
+            <a:schemeClr val="lt1"/>
+          </a:fontRef>
+        </p:style>
+        <p:txBody>
+          <a:bodyPr rtlCol="0" anchor="ctr"/>
+          <a:lstStyle/>
+          <a:p>
+            <a:pPr algn="ctr"/>
+          </a:p>
+        </p:txBody>
+      </p:sp>
+      <p:sp>
+        <p:nvSpPr>
+          <p:cNvPr id="13" name="TextBox 12"/>
+          <p:cNvSpPr txBox="1"/>
+          <p:nvPr/>
+        </p:nvSpPr>
+        <p:spPr>
+          <a:xfrm>
+            <a:off x="822960" y="4754880"/>
+            <a:ext cx="1819656" cy="274320"/>
+          </a:xfrm>
+          <a:prstGeom prst="rect">
+            <a:avLst/>
+          </a:prstGeom>
+          <a:noFill/>
+        </p:spPr>
+        <p:txBody>
+          <a:bodyPr wrap="square" anchor="t" lIns="0" rIns="0" tIns="0" bIns="0">
+            <a:spAutoFit/>
+          </a:bodyPr>
+          <a:lstStyle/>
+          <a:p>
+            <a:pPr algn="ctr"/>
+            <a:r>
+              <a:rPr sz="1100" b="1">
+                <a:solidFill>
+                  <a:srgbClr val="5B6775"/>
+                </a:solidFill>
+                <a:latin typeface="Poppins"/>
+              </a:rPr>
+              <a:t>EN NUESTRO RI</a:t>
+            </a:r>
+          </a:p>
+        </p:txBody>
+      </p:sp>
+      <p:sp>
+        <p:nvSpPr>
+          <p:cNvPr id="14" name="Rounded Rectangle 13"/>
+          <p:cNvSpPr/>
+          <p:nvPr/>
+        </p:nvSpPr>
+        <p:spPr>
+          <a:xfrm>
+            <a:off x="868680" y="5047488"/>
+            <a:ext cx="1728216" cy="941832"/>
+          </a:xfrm>
+          <a:prstGeom prst="roundRect">
+            <a:avLst>
+              <a:gd name="adj" fmla="val 14000"/>
+            </a:avLst>
+          </a:prstGeom>
+          <a:solidFill>
+            <a:srgbClr val="E6EEEE"/>
+          </a:solidFill>
+          <a:ln>
+            <a:noFill/>
+          </a:ln>
+          <a:effectLst/>
+        </p:spPr>
+        <p:style>
+          <a:lnRef idx="1">
+            <a:schemeClr val="accent1"/>
+          </a:lnRef>
+          <a:fillRef idx="3">
+            <a:schemeClr val="accent1"/>
+          </a:fillRef>
+          <a:effectRef idx="2">
+            <a:schemeClr val="accent1"/>
+          </a:effectRef>
+          <a:fontRef idx="minor">
+            <a:schemeClr val="lt1"/>
+          </a:fontRef>
+        </p:style>
+        <p:txBody>
+          <a:bodyPr rtlCol="0" anchor="ctr"/>
+          <a:lstStyle/>
+          <a:p>
+            <a:pPr algn="ctr"/>
+          </a:p>
+        </p:txBody>
+      </p:sp>
+      <p:sp>
+        <p:nvSpPr>
+          <p:cNvPr id="15" name="TextBox 14"/>
+          <p:cNvSpPr txBox="1"/>
+          <p:nvPr/>
+        </p:nvSpPr>
+        <p:spPr>
+          <a:xfrm>
+            <a:off x="914400" y="5093208"/>
+            <a:ext cx="1636776" cy="438912"/>
+          </a:xfrm>
+          <a:prstGeom prst="rect">
+            <a:avLst/>
+          </a:prstGeom>
+          <a:noFill/>
+        </p:spPr>
+        <p:txBody>
+          <a:bodyPr wrap="square" anchor="ctr" lIns="0" rIns="0" tIns="0" bIns="0">
+            <a:spAutoFit/>
+          </a:bodyPr>
+          <a:lstStyle/>
+          <a:p>
+            <a:pPr algn="ctr"/>
+            <a:r>
+              <a:rPr sz="1700" b="1">
+                <a:solidFill>
+                  <a:srgbClr val="0E7C7B"/>
+                </a:solidFill>
+                <a:latin typeface="Poppins"/>
+              </a:rPr>
+              <a:t>Arts. 134°–136°</a:t>
+            </a:r>
+          </a:p>
+        </p:txBody>
+      </p:sp>
+      <p:sp>
+        <p:nvSpPr>
+          <p:cNvPr id="16" name="TextBox 15"/>
+          <p:cNvSpPr txBox="1"/>
+          <p:nvPr/>
+        </p:nvSpPr>
+        <p:spPr>
+          <a:xfrm>
+            <a:off x="914400" y="5513832"/>
+            <a:ext cx="1636776" cy="429768"/>
+          </a:xfrm>
+          <a:prstGeom prst="rect">
+            <a:avLst/>
+          </a:prstGeom>
+          <a:noFill/>
+        </p:spPr>
+        <p:txBody>
+          <a:bodyPr wrap="square" anchor="ctr" lIns="0" rIns="0" tIns="0" bIns="0">
+            <a:spAutoFit/>
+          </a:bodyPr>
+          <a:lstStyle/>
+          <a:p>
+            <a:pPr algn="ctr">
+              <a:lnSpc>
+                <a:spcPct val="95000"/>
+              </a:lnSpc>
+            </a:pPr>
+            <a:r>
+              <a:rPr sz="1100" b="0">
+                <a:solidFill>
+                  <a:srgbClr val="1F2A37"/>
+                </a:solidFill>
+                <a:latin typeface="Poppins"/>
+              </a:rPr>
+              <a:t>Tít. V · Cap. I · Normas y deberes</a:t>
+            </a:r>
+          </a:p>
+        </p:txBody>
+      </p:sp>
+      <p:sp>
+        <p:nvSpPr>
+          <p:cNvPr id="17" name="Rounded Rectangle 16"/>
+          <p:cNvSpPr/>
+          <p:nvPr/>
+        </p:nvSpPr>
+        <p:spPr>
+          <a:xfrm>
+            <a:off x="2930652" y="1828800"/>
+            <a:ext cx="2002536" cy="4343400"/>
+          </a:xfrm>
+          <a:prstGeom prst="roundRect">
+            <a:avLst>
+              <a:gd name="adj" fmla="val 7000"/>
+            </a:avLst>
+          </a:prstGeom>
+          <a:solidFill>
+            <a:srgbClr val="FFFFFF"/>
+          </a:solidFill>
+          <a:ln>
+            <a:noFill/>
+          </a:ln>
+          <a:effectLst/>
+        </p:spPr>
+        <p:style>
+          <a:lnRef idx="1">
+            <a:schemeClr val="accent1"/>
+          </a:lnRef>
+          <a:fillRef idx="3">
+            <a:schemeClr val="accent1"/>
+          </a:fillRef>
+          <a:effectRef idx="2">
+            <a:schemeClr val="accent1"/>
+          </a:effectRef>
+          <a:fontRef idx="minor">
+            <a:schemeClr val="lt1"/>
+          </a:fontRef>
+        </p:style>
+        <p:txBody>
+          <a:bodyPr rtlCol="0" anchor="ctr"/>
+          <a:lstStyle/>
+          <a:p>
+            <a:pPr algn="ctr"/>
+          </a:p>
+        </p:txBody>
+      </p:sp>
+      <p:sp>
+        <p:nvSpPr>
+          <p:cNvPr id="18" name="Rounded Rectangle 17"/>
+          <p:cNvSpPr/>
+          <p:nvPr/>
+        </p:nvSpPr>
+        <p:spPr>
+          <a:xfrm>
+            <a:off x="2930652" y="1828800"/>
+            <a:ext cx="2002536" cy="1325880"/>
+          </a:xfrm>
+          <a:prstGeom prst="roundRect">
+            <a:avLst>
+              <a:gd name="adj" fmla="val 16000"/>
+            </a:avLst>
+          </a:prstGeom>
+          <a:solidFill>
+            <a:srgbClr val="0E7C7B"/>
+          </a:solidFill>
+          <a:ln>
+            <a:noFill/>
+          </a:ln>
+          <a:effectLst/>
+        </p:spPr>
+        <p:style>
+          <a:lnRef idx="1">
+            <a:schemeClr val="accent1"/>
+          </a:lnRef>
+          <a:fillRef idx="3">
+            <a:schemeClr val="accent1"/>
+          </a:fillRef>
+          <a:effectRef idx="2">
+            <a:schemeClr val="accent1"/>
+          </a:effectRef>
+          <a:fontRef idx="minor">
+            <a:schemeClr val="lt1"/>
+          </a:fontRef>
+        </p:style>
+        <p:txBody>
+          <a:bodyPr rtlCol="0" anchor="ctr"/>
+          <a:lstStyle/>
+          <a:p>
+            <a:pPr algn="ctr"/>
+          </a:p>
+        </p:txBody>
+      </p:sp>
+      <p:sp>
+        <p:nvSpPr>
+          <p:cNvPr id="19" name="Rectangle 18"/>
+          <p:cNvSpPr/>
+          <p:nvPr/>
+        </p:nvSpPr>
+        <p:spPr>
+          <a:xfrm>
+            <a:off x="2930652" y="2788920"/>
+            <a:ext cx="2002536" cy="365760"/>
+          </a:xfrm>
+          <a:prstGeom prst="rect">
+            <a:avLst/>
+          </a:prstGeom>
+          <a:solidFill>
+            <a:srgbClr val="0E7C7B"/>
+          </a:solidFill>
+          <a:ln>
+            <a:noFill/>
+          </a:ln>
+          <a:effectLst/>
+        </p:spPr>
+        <p:style>
+          <a:lnRef idx="1">
+            <a:schemeClr val="accent1"/>
+          </a:lnRef>
+          <a:fillRef idx="3">
+            <a:schemeClr val="accent1"/>
+          </a:fillRef>
+          <a:effectRef idx="2">
+            <a:schemeClr val="accent1"/>
+          </a:effectRef>
+          <a:fontRef idx="minor">
+            <a:schemeClr val="lt1"/>
+          </a:fontRef>
+        </p:style>
+        <p:txBody>
+          <a:bodyPr rtlCol="0" anchor="ctr"/>
+          <a:lstStyle/>
+          <a:p>
+            <a:pPr algn="ctr"/>
+          </a:p>
+        </p:txBody>
+      </p:sp>
+      <p:sp>
+        <p:nvSpPr>
+          <p:cNvPr id="20" name="Oval 19"/>
+          <p:cNvSpPr/>
+          <p:nvPr/>
+        </p:nvSpPr>
+        <p:spPr>
+          <a:xfrm>
+            <a:off x="3575304" y="1993392"/>
+            <a:ext cx="713232" cy="713232"/>
+          </a:xfrm>
+          <a:prstGeom prst="ellipse">
+            <a:avLst/>
+          </a:prstGeom>
+          <a:solidFill>
+            <a:srgbClr val="FFFFFF">
+              <a:alpha val="22000"/>
+            </a:srgbClr>
+          </a:solidFill>
+          <a:ln>
+            <a:noFill/>
+          </a:ln>
+          <a:effectLst/>
+        </p:spPr>
+        <p:style>
+          <a:lnRef idx="1">
+            <a:schemeClr val="accent1"/>
+          </a:lnRef>
+          <a:fillRef idx="3">
+            <a:schemeClr val="accent1"/>
+          </a:fillRef>
+          <a:effectRef idx="2">
+            <a:schemeClr val="accent1"/>
+          </a:effectRef>
+          <a:fontRef idx="minor">
+            <a:schemeClr val="lt1"/>
+          </a:fontRef>
+        </p:style>
+        <p:txBody>
+          <a:bodyPr rtlCol="0" anchor="ctr"/>
+          <a:lstStyle/>
+          <a:p>
+            <a:pPr algn="ctr"/>
+          </a:p>
+        </p:txBody>
+      </p:sp>
+      <p:pic>
+        <p:nvPicPr>
+          <p:cNvPr id="21" name="Picture 20" descr="f19d_FFFFFF.png"/>
+          <p:cNvPicPr>
+            <a:picLocks noChangeAspect="1"/>
+          </p:cNvPicPr>
+          <p:nvPr/>
+        </p:nvPicPr>
+        <p:blipFill>
+          <a:blip r:embed="rId3"/>
+          <a:stretch>
+            <a:fillRect/>
+          </a:stretch>
+        </p:blipFill>
+        <p:spPr>
+          <a:xfrm>
+            <a:off x="3712464" y="2130552"/>
+            <a:ext cx="438912" cy="438912"/>
+          </a:xfrm>
+          <a:prstGeom prst="rect">
+            <a:avLst/>
+          </a:prstGeom>
+        </p:spPr>
+      </p:pic>
+      <p:sp>
+        <p:nvSpPr>
+          <p:cNvPr id="22" name="TextBox 21"/>
+          <p:cNvSpPr txBox="1"/>
+          <p:nvPr/>
+        </p:nvSpPr>
+        <p:spPr>
+          <a:xfrm>
+            <a:off x="3022092" y="2743200"/>
+            <a:ext cx="1819656" cy="365760"/>
+          </a:xfrm>
+          <a:prstGeom prst="rect">
+            <a:avLst/>
+          </a:prstGeom>
+          <a:noFill/>
+        </p:spPr>
+        <p:txBody>
+          <a:bodyPr wrap="square" anchor="ctr" lIns="0" rIns="0" tIns="0" bIns="0">
+            <a:spAutoFit/>
+          </a:bodyPr>
+          <a:lstStyle/>
+          <a:p>
+            <a:pPr algn="ctr"/>
+            <a:r>
+              <a:rPr sz="1600" b="1">
+                <a:solidFill>
+                  <a:srgbClr val="FFFFFF"/>
+                </a:solidFill>
+                <a:latin typeface="Poppins"/>
+              </a:rPr>
+              <a:t>Art. 9</a:t>
+            </a:r>
+          </a:p>
+        </p:txBody>
+      </p:sp>
+      <p:sp>
+        <p:nvSpPr>
+          <p:cNvPr id="23" name="TextBox 22"/>
+          <p:cNvSpPr txBox="1"/>
+          <p:nvPr/>
+        </p:nvSpPr>
+        <p:spPr>
+          <a:xfrm>
+            <a:off x="3113532" y="3337560"/>
+            <a:ext cx="1636776" cy="960120"/>
+          </a:xfrm>
+          <a:prstGeom prst="rect">
+            <a:avLst/>
+          </a:prstGeom>
+          <a:noFill/>
+        </p:spPr>
+        <p:txBody>
+          <a:bodyPr wrap="square" anchor="ctr" lIns="0" rIns="0" tIns="0" bIns="0">
+            <a:spAutoFit/>
+          </a:bodyPr>
+          <a:lstStyle/>
+          <a:p>
+            <a:pPr algn="ctr">
+              <a:lnSpc>
+                <a:spcPct val="100000"/>
+              </a:lnSpc>
+            </a:pPr>
+            <a:r>
+              <a:rPr sz="1600" b="1">
+                <a:solidFill>
+                  <a:srgbClr val="0F2A44"/>
+                </a:solidFill>
+                <a:latin typeface="Poppins"/>
+              </a:rPr>
+              <a:t>Tutoría: uso seguro del celular</a:t>
+            </a:r>
+          </a:p>
+        </p:txBody>
+      </p:sp>
+      <p:sp>
+        <p:nvSpPr>
+          <p:cNvPr id="24" name="Down Arrow 23"/>
+          <p:cNvSpPr/>
+          <p:nvPr/>
+        </p:nvSpPr>
+        <p:spPr>
+          <a:xfrm>
+            <a:off x="3739896" y="4407408"/>
+            <a:ext cx="384048" cy="274320"/>
+          </a:xfrm>
+          <a:prstGeom prst="downArrow">
+            <a:avLst/>
+          </a:prstGeom>
+          <a:solidFill>
+            <a:srgbClr val="E0A526"/>
+          </a:solidFill>
+          <a:ln>
+            <a:noFill/>
+          </a:ln>
+          <a:effectLst/>
+        </p:spPr>
+        <p:style>
+          <a:lnRef idx="1">
+            <a:schemeClr val="accent1"/>
+          </a:lnRef>
+          <a:fillRef idx="3">
+            <a:schemeClr val="accent1"/>
+          </a:fillRef>
+          <a:effectRef idx="2">
+            <a:schemeClr val="accent1"/>
+          </a:effectRef>
+          <a:fontRef idx="minor">
+            <a:schemeClr val="lt1"/>
+          </a:fontRef>
+        </p:style>
+        <p:txBody>
+          <a:bodyPr rtlCol="0" anchor="ctr"/>
+          <a:lstStyle/>
+          <a:p>
+            <a:pPr algn="ctr"/>
+          </a:p>
+        </p:txBody>
+      </p:sp>
+      <p:sp>
+        <p:nvSpPr>
+          <p:cNvPr id="25" name="TextBox 24"/>
+          <p:cNvSpPr txBox="1"/>
+          <p:nvPr/>
+        </p:nvSpPr>
+        <p:spPr>
+          <a:xfrm>
+            <a:off x="3022092" y="4754880"/>
+            <a:ext cx="1819656" cy="274320"/>
+          </a:xfrm>
+          <a:prstGeom prst="rect">
+            <a:avLst/>
+          </a:prstGeom>
+          <a:noFill/>
+        </p:spPr>
+        <p:txBody>
+          <a:bodyPr wrap="square" anchor="t" lIns="0" rIns="0" tIns="0" bIns="0">
+            <a:spAutoFit/>
+          </a:bodyPr>
+          <a:lstStyle/>
+          <a:p>
+            <a:pPr algn="ctr"/>
+            <a:r>
+              <a:rPr sz="1100" b="1">
+                <a:solidFill>
+                  <a:srgbClr val="5B6775"/>
+                </a:solidFill>
+                <a:latin typeface="Poppins"/>
+              </a:rPr>
+              <a:t>EN NUESTRO RI</a:t>
+            </a:r>
+          </a:p>
+        </p:txBody>
+      </p:sp>
+      <p:sp>
+        <p:nvSpPr>
+          <p:cNvPr id="26" name="Rounded Rectangle 25"/>
+          <p:cNvSpPr/>
+          <p:nvPr/>
+        </p:nvSpPr>
+        <p:spPr>
+          <a:xfrm>
+            <a:off x="3067812" y="5047488"/>
+            <a:ext cx="1728216" cy="941832"/>
+          </a:xfrm>
+          <a:prstGeom prst="roundRect">
+            <a:avLst>
+              <a:gd name="adj" fmla="val 14000"/>
+            </a:avLst>
+          </a:prstGeom>
+          <a:solidFill>
+            <a:srgbClr val="E6EEEE"/>
+          </a:solidFill>
+          <a:ln>
+            <a:noFill/>
+          </a:ln>
+          <a:effectLst/>
+        </p:spPr>
+        <p:style>
+          <a:lnRef idx="1">
+            <a:schemeClr val="accent1"/>
+          </a:lnRef>
+          <a:fillRef idx="3">
+            <a:schemeClr val="accent1"/>
+          </a:fillRef>
+          <a:effectRef idx="2">
+            <a:schemeClr val="accent1"/>
+          </a:effectRef>
+          <a:fontRef idx="minor">
+            <a:schemeClr val="lt1"/>
+          </a:fontRef>
+        </p:style>
+        <p:txBody>
+          <a:bodyPr rtlCol="0" anchor="ctr"/>
+          <a:lstStyle/>
+          <a:p>
+            <a:pPr algn="ctr"/>
+          </a:p>
+        </p:txBody>
+      </p:sp>
+      <p:sp>
+        <p:nvSpPr>
+          <p:cNvPr id="27" name="TextBox 26"/>
+          <p:cNvSpPr txBox="1"/>
+          <p:nvPr/>
+        </p:nvSpPr>
+        <p:spPr>
+          <a:xfrm>
+            <a:off x="3113532" y="5093208"/>
+            <a:ext cx="1636776" cy="438912"/>
+          </a:xfrm>
+          <a:prstGeom prst="rect">
+            <a:avLst/>
+          </a:prstGeom>
+          <a:noFill/>
+        </p:spPr>
+        <p:txBody>
+          <a:bodyPr wrap="square" anchor="ctr" lIns="0" rIns="0" tIns="0" bIns="0">
+            <a:spAutoFit/>
+          </a:bodyPr>
+          <a:lstStyle/>
+          <a:p>
+            <a:pPr algn="ctr"/>
+            <a:r>
+              <a:rPr sz="1700" b="1">
+                <a:solidFill>
+                  <a:srgbClr val="0E7C7B"/>
+                </a:solidFill>
+                <a:latin typeface="Poppins"/>
+              </a:rPr>
+              <a:t>Art. 103°</a:t>
+            </a:r>
+          </a:p>
+        </p:txBody>
+      </p:sp>
+      <p:sp>
+        <p:nvSpPr>
+          <p:cNvPr id="28" name="TextBox 27"/>
+          <p:cNvSpPr txBox="1"/>
+          <p:nvPr/>
+        </p:nvSpPr>
+        <p:spPr>
+          <a:xfrm>
+            <a:off x="3113532" y="5513832"/>
+            <a:ext cx="1636776" cy="429768"/>
+          </a:xfrm>
+          <a:prstGeom prst="rect">
+            <a:avLst/>
+          </a:prstGeom>
+          <a:noFill/>
+        </p:spPr>
+        <p:txBody>
+          <a:bodyPr wrap="square" anchor="ctr" lIns="0" rIns="0" tIns="0" bIns="0">
+            <a:spAutoFit/>
+          </a:bodyPr>
+          <a:lstStyle/>
+          <a:p>
+            <a:pPr algn="ctr">
+              <a:lnSpc>
+                <a:spcPct val="95000"/>
+              </a:lnSpc>
+            </a:pPr>
+            <a:r>
+              <a:rPr sz="1100" b="0">
+                <a:solidFill>
+                  <a:srgbClr val="1F2A37"/>
+                </a:solidFill>
+                <a:latin typeface="Poppins"/>
+              </a:rPr>
+              <a:t>Tít. IV · Cap. IV · Tutoría</a:t>
+            </a:r>
+          </a:p>
+        </p:txBody>
+      </p:sp>
+      <p:sp>
+        <p:nvSpPr>
+          <p:cNvPr id="29" name="Rounded Rectangle 28"/>
+          <p:cNvSpPr/>
+          <p:nvPr/>
+        </p:nvSpPr>
+        <p:spPr>
+          <a:xfrm>
+            <a:off x="5129783" y="1828800"/>
+            <a:ext cx="2002536" cy="4343400"/>
+          </a:xfrm>
+          <a:prstGeom prst="roundRect">
+            <a:avLst>
+              <a:gd name="adj" fmla="val 7000"/>
+            </a:avLst>
+          </a:prstGeom>
+          <a:solidFill>
+            <a:srgbClr val="FFFFFF"/>
+          </a:solidFill>
+          <a:ln>
+            <a:noFill/>
+          </a:ln>
+          <a:effectLst/>
+        </p:spPr>
+        <p:style>
+          <a:lnRef idx="1">
+            <a:schemeClr val="accent1"/>
+          </a:lnRef>
+          <a:fillRef idx="3">
+            <a:schemeClr val="accent1"/>
+          </a:fillRef>
+          <a:effectRef idx="2">
+            <a:schemeClr val="accent1"/>
+          </a:effectRef>
+          <a:fontRef idx="minor">
+            <a:schemeClr val="lt1"/>
+          </a:fontRef>
+        </p:style>
+        <p:txBody>
+          <a:bodyPr rtlCol="0" anchor="ctr"/>
+          <a:lstStyle/>
+          <a:p>
+            <a:pPr algn="ctr"/>
+          </a:p>
+        </p:txBody>
+      </p:sp>
+      <p:sp>
+        <p:nvSpPr>
+          <p:cNvPr id="30" name="Rounded Rectangle 29"/>
+          <p:cNvSpPr/>
+          <p:nvPr/>
+        </p:nvSpPr>
+        <p:spPr>
+          <a:xfrm>
+            <a:off x="5129783" y="1828800"/>
+            <a:ext cx="2002536" cy="1325880"/>
+          </a:xfrm>
+          <a:prstGeom prst="roundRect">
+            <a:avLst>
+              <a:gd name="adj" fmla="val 16000"/>
+            </a:avLst>
+          </a:prstGeom>
+          <a:solidFill>
+            <a:srgbClr val="C85A3A"/>
+          </a:solidFill>
+          <a:ln>
+            <a:noFill/>
+          </a:ln>
+          <a:effectLst/>
+        </p:spPr>
+        <p:style>
+          <a:lnRef idx="1">
+            <a:schemeClr val="accent1"/>
+          </a:lnRef>
+          <a:fillRef idx="3">
+            <a:schemeClr val="accent1"/>
+          </a:fillRef>
+          <a:effectRef idx="2">
+            <a:schemeClr val="accent1"/>
+          </a:effectRef>
+          <a:fontRef idx="minor">
+            <a:schemeClr val="lt1"/>
+          </a:fontRef>
+        </p:style>
+        <p:txBody>
+          <a:bodyPr rtlCol="0" anchor="ctr"/>
+          <a:lstStyle/>
+          <a:p>
+            <a:pPr algn="ctr"/>
+          </a:p>
+        </p:txBody>
+      </p:sp>
+      <p:sp>
+        <p:nvSpPr>
+          <p:cNvPr id="31" name="Rectangle 30"/>
+          <p:cNvSpPr/>
+          <p:nvPr/>
+        </p:nvSpPr>
+        <p:spPr>
+          <a:xfrm>
+            <a:off x="5129783" y="2788920"/>
+            <a:ext cx="2002536" cy="365760"/>
+          </a:xfrm>
+          <a:prstGeom prst="rect">
+            <a:avLst/>
+          </a:prstGeom>
+          <a:solidFill>
+            <a:srgbClr val="C85A3A"/>
+          </a:solidFill>
+          <a:ln>
+            <a:noFill/>
+          </a:ln>
+          <a:effectLst/>
+        </p:spPr>
+        <p:style>
+          <a:lnRef idx="1">
+            <a:schemeClr val="accent1"/>
+          </a:lnRef>
+          <a:fillRef idx="3">
+            <a:schemeClr val="accent1"/>
+          </a:fillRef>
+          <a:effectRef idx="2">
+            <a:schemeClr val="accent1"/>
+          </a:effectRef>
+          <a:fontRef idx="minor">
+            <a:schemeClr val="lt1"/>
+          </a:fontRef>
+        </p:style>
+        <p:txBody>
+          <a:bodyPr rtlCol="0" anchor="ctr"/>
+          <a:lstStyle/>
+          <a:p>
+            <a:pPr algn="ctr"/>
+          </a:p>
+        </p:txBody>
+      </p:sp>
+      <p:sp>
+        <p:nvSpPr>
+          <p:cNvPr id="32" name="Oval 31"/>
+          <p:cNvSpPr/>
+          <p:nvPr/>
+        </p:nvSpPr>
+        <p:spPr>
+          <a:xfrm>
+            <a:off x="5774436" y="1993392"/>
+            <a:ext cx="713232" cy="713232"/>
+          </a:xfrm>
+          <a:prstGeom prst="ellipse">
+            <a:avLst/>
+          </a:prstGeom>
+          <a:solidFill>
+            <a:srgbClr val="FFFFFF">
+              <a:alpha val="22000"/>
+            </a:srgbClr>
+          </a:solidFill>
+          <a:ln>
+            <a:noFill/>
+          </a:ln>
+          <a:effectLst/>
+        </p:spPr>
+        <p:style>
+          <a:lnRef idx="1">
+            <a:schemeClr val="accent1"/>
+          </a:lnRef>
+          <a:fillRef idx="3">
+            <a:schemeClr val="accent1"/>
+          </a:fillRef>
+          <a:effectRef idx="2">
+            <a:schemeClr val="accent1"/>
+          </a:effectRef>
+          <a:fontRef idx="minor">
+            <a:schemeClr val="lt1"/>
+          </a:fontRef>
+        </p:style>
+        <p:txBody>
+          <a:bodyPr rtlCol="0" anchor="ctr"/>
+          <a:lstStyle/>
+          <a:p>
+            <a:pPr algn="ctr"/>
+          </a:p>
+        </p:txBody>
+      </p:sp>
+      <p:pic>
+        <p:nvPicPr>
+          <p:cNvPr id="33" name="Picture 32" descr="f015_FFFFFF.png"/>
+          <p:cNvPicPr>
+            <a:picLocks noChangeAspect="1"/>
+          </p:cNvPicPr>
+          <p:nvPr/>
+        </p:nvPicPr>
+        <p:blipFill>
+          <a:blip r:embed="rId4"/>
+          <a:stretch>
+            <a:fillRect/>
+          </a:stretch>
+        </p:blipFill>
+        <p:spPr>
+          <a:xfrm>
+            <a:off x="5911596" y="2130552"/>
+            <a:ext cx="438912" cy="438912"/>
+          </a:xfrm>
+          <a:prstGeom prst="rect">
+            <a:avLst/>
+          </a:prstGeom>
+        </p:spPr>
+      </p:pic>
+      <p:sp>
+        <p:nvSpPr>
+          <p:cNvPr id="34" name="TextBox 33"/>
+          <p:cNvSpPr txBox="1"/>
+          <p:nvPr/>
+        </p:nvSpPr>
+        <p:spPr>
+          <a:xfrm>
+            <a:off x="5221223" y="2743200"/>
+            <a:ext cx="1819656" cy="365760"/>
+          </a:xfrm>
+          <a:prstGeom prst="rect">
+            <a:avLst/>
+          </a:prstGeom>
+          <a:noFill/>
+        </p:spPr>
+        <p:txBody>
+          <a:bodyPr wrap="square" anchor="ctr" lIns="0" rIns="0" tIns="0" bIns="0">
+            <a:spAutoFit/>
+          </a:bodyPr>
+          <a:lstStyle/>
+          <a:p>
+            <a:pPr algn="ctr"/>
+            <a:r>
+              <a:rPr sz="1600" b="1">
+                <a:solidFill>
+                  <a:srgbClr val="FFFFFF"/>
+                </a:solidFill>
+                <a:latin typeface="Poppins"/>
+              </a:rPr>
+              <a:t>Arts. 10 y 13</a:t>
+            </a:r>
+          </a:p>
+        </p:txBody>
+      </p:sp>
+      <p:sp>
+        <p:nvSpPr>
+          <p:cNvPr id="35" name="TextBox 34"/>
+          <p:cNvSpPr txBox="1"/>
+          <p:nvPr/>
+        </p:nvSpPr>
+        <p:spPr>
+          <a:xfrm>
+            <a:off x="5312664" y="3337560"/>
+            <a:ext cx="1636776" cy="960120"/>
+          </a:xfrm>
+          <a:prstGeom prst="rect">
+            <a:avLst/>
+          </a:prstGeom>
+          <a:noFill/>
+        </p:spPr>
+        <p:txBody>
+          <a:bodyPr wrap="square" anchor="ctr" lIns="0" rIns="0" tIns="0" bIns="0">
+            <a:spAutoFit/>
+          </a:bodyPr>
+          <a:lstStyle/>
+          <a:p>
+            <a:pPr algn="ctr">
+              <a:lnSpc>
+                <a:spcPct val="100000"/>
+              </a:lnSpc>
+            </a:pPr>
+            <a:r>
+              <a:rPr sz="1600" b="1">
+                <a:solidFill>
+                  <a:srgbClr val="0F2A44"/>
+                </a:solidFill>
+                <a:latin typeface="Poppins"/>
+              </a:rPr>
+              <a:t>Compromisos y orientación a padres</a:t>
+            </a:r>
+          </a:p>
+        </p:txBody>
+      </p:sp>
+      <p:sp>
+        <p:nvSpPr>
+          <p:cNvPr id="36" name="Down Arrow 35"/>
+          <p:cNvSpPr/>
+          <p:nvPr/>
+        </p:nvSpPr>
+        <p:spPr>
+          <a:xfrm>
+            <a:off x="5939027" y="4407408"/>
+            <a:ext cx="384048" cy="274320"/>
+          </a:xfrm>
+          <a:prstGeom prst="downArrow">
+            <a:avLst/>
+          </a:prstGeom>
+          <a:solidFill>
+            <a:srgbClr val="E0A526"/>
+          </a:solidFill>
+          <a:ln>
+            <a:noFill/>
+          </a:ln>
+          <a:effectLst/>
+        </p:spPr>
+        <p:style>
+          <a:lnRef idx="1">
+            <a:schemeClr val="accent1"/>
+          </a:lnRef>
+          <a:fillRef idx="3">
+            <a:schemeClr val="accent1"/>
+          </a:fillRef>
+          <a:effectRef idx="2">
+            <a:schemeClr val="accent1"/>
+          </a:effectRef>
+          <a:fontRef idx="minor">
+            <a:schemeClr val="lt1"/>
+          </a:fontRef>
+        </p:style>
+        <p:txBody>
+          <a:bodyPr rtlCol="0" anchor="ctr"/>
+          <a:lstStyle/>
+          <a:p>
+            <a:pPr algn="ctr"/>
+          </a:p>
+        </p:txBody>
+      </p:sp>
+      <p:sp>
+        <p:nvSpPr>
+          <p:cNvPr id="37" name="TextBox 36"/>
+          <p:cNvSpPr txBox="1"/>
+          <p:nvPr/>
+        </p:nvSpPr>
+        <p:spPr>
+          <a:xfrm>
+            <a:off x="5221223" y="4754880"/>
+            <a:ext cx="1819656" cy="274320"/>
+          </a:xfrm>
+          <a:prstGeom prst="rect">
+            <a:avLst/>
+          </a:prstGeom>
+          <a:noFill/>
+        </p:spPr>
+        <p:txBody>
+          <a:bodyPr wrap="square" anchor="t" lIns="0" rIns="0" tIns="0" bIns="0">
+            <a:spAutoFit/>
+          </a:bodyPr>
+          <a:lstStyle/>
+          <a:p>
+            <a:pPr algn="ctr"/>
+            <a:r>
+              <a:rPr sz="1100" b="1">
+                <a:solidFill>
+                  <a:srgbClr val="5B6775"/>
+                </a:solidFill>
+                <a:latin typeface="Poppins"/>
+              </a:rPr>
+              <a:t>EN NUESTRO RI</a:t>
+            </a:r>
+          </a:p>
+        </p:txBody>
+      </p:sp>
+      <p:sp>
+        <p:nvSpPr>
+          <p:cNvPr id="38" name="Rounded Rectangle 37"/>
+          <p:cNvSpPr/>
+          <p:nvPr/>
+        </p:nvSpPr>
+        <p:spPr>
+          <a:xfrm>
+            <a:off x="5266944" y="5047488"/>
+            <a:ext cx="1728216" cy="941832"/>
+          </a:xfrm>
+          <a:prstGeom prst="roundRect">
+            <a:avLst>
+              <a:gd name="adj" fmla="val 14000"/>
+            </a:avLst>
+          </a:prstGeom>
+          <a:solidFill>
+            <a:srgbClr val="E6EEEE"/>
+          </a:solidFill>
+          <a:ln>
+            <a:noFill/>
+          </a:ln>
+          <a:effectLst/>
+        </p:spPr>
+        <p:style>
+          <a:lnRef idx="1">
+            <a:schemeClr val="accent1"/>
+          </a:lnRef>
+          <a:fillRef idx="3">
+            <a:schemeClr val="accent1"/>
+          </a:fillRef>
+          <a:effectRef idx="2">
+            <a:schemeClr val="accent1"/>
+          </a:effectRef>
+          <a:fontRef idx="minor">
+            <a:schemeClr val="lt1"/>
+          </a:fontRef>
+        </p:style>
+        <p:txBody>
+          <a:bodyPr rtlCol="0" anchor="ctr"/>
+          <a:lstStyle/>
+          <a:p>
+            <a:pPr algn="ctr"/>
+          </a:p>
+        </p:txBody>
+      </p:sp>
+      <p:sp>
+        <p:nvSpPr>
+          <p:cNvPr id="39" name="TextBox 38"/>
+          <p:cNvSpPr txBox="1"/>
+          <p:nvPr/>
+        </p:nvSpPr>
+        <p:spPr>
+          <a:xfrm>
+            <a:off x="5312664" y="5093208"/>
+            <a:ext cx="1636776" cy="438912"/>
+          </a:xfrm>
+          <a:prstGeom prst="rect">
+            <a:avLst/>
+          </a:prstGeom>
+          <a:noFill/>
+        </p:spPr>
+        <p:txBody>
+          <a:bodyPr wrap="square" anchor="ctr" lIns="0" rIns="0" tIns="0" bIns="0">
+            <a:spAutoFit/>
+          </a:bodyPr>
+          <a:lstStyle/>
+          <a:p>
+            <a:pPr algn="ctr"/>
+            <a:r>
+              <a:rPr sz="1700" b="1">
+                <a:solidFill>
+                  <a:srgbClr val="C85A3A"/>
+                </a:solidFill>
+                <a:latin typeface="Poppins"/>
+              </a:rPr>
+              <a:t>Art. 152°</a:t>
+            </a:r>
+          </a:p>
+        </p:txBody>
+      </p:sp>
+      <p:sp>
+        <p:nvSpPr>
+          <p:cNvPr id="40" name="TextBox 39"/>
+          <p:cNvSpPr txBox="1"/>
+          <p:nvPr/>
+        </p:nvSpPr>
+        <p:spPr>
+          <a:xfrm>
+            <a:off x="5312664" y="5513832"/>
+            <a:ext cx="1636776" cy="429768"/>
+          </a:xfrm>
+          <a:prstGeom prst="rect">
+            <a:avLst/>
+          </a:prstGeom>
+          <a:noFill/>
+        </p:spPr>
+        <p:txBody>
+          <a:bodyPr wrap="square" anchor="ctr" lIns="0" rIns="0" tIns="0" bIns="0">
+            <a:spAutoFit/>
+          </a:bodyPr>
+          <a:lstStyle/>
+          <a:p>
+            <a:pPr algn="ctr">
+              <a:lnSpc>
+                <a:spcPct val="95000"/>
+              </a:lnSpc>
+            </a:pPr>
+            <a:r>
+              <a:rPr sz="1100" b="0">
+                <a:solidFill>
+                  <a:srgbClr val="1F2A37"/>
+                </a:solidFill>
+                <a:latin typeface="Poppins"/>
+              </a:rPr>
+              <a:t>Tít. V · Cap. VI · Padres</a:t>
+            </a:r>
+          </a:p>
+        </p:txBody>
+      </p:sp>
+      <p:sp>
+        <p:nvSpPr>
+          <p:cNvPr id="41" name="Rounded Rectangle 40"/>
+          <p:cNvSpPr/>
+          <p:nvPr/>
+        </p:nvSpPr>
+        <p:spPr>
+          <a:xfrm>
+            <a:off x="7328916" y="1828800"/>
+            <a:ext cx="2002536" cy="4343400"/>
+          </a:xfrm>
+          <a:prstGeom prst="roundRect">
+            <a:avLst>
+              <a:gd name="adj" fmla="val 7000"/>
+            </a:avLst>
+          </a:prstGeom>
+          <a:solidFill>
+            <a:srgbClr val="FFFFFF"/>
+          </a:solidFill>
+          <a:ln>
+            <a:noFill/>
+          </a:ln>
+          <a:effectLst/>
+        </p:spPr>
+        <p:style>
+          <a:lnRef idx="1">
+            <a:schemeClr val="accent1"/>
+          </a:lnRef>
+          <a:fillRef idx="3">
+            <a:schemeClr val="accent1"/>
+          </a:fillRef>
+          <a:effectRef idx="2">
+            <a:schemeClr val="accent1"/>
+          </a:effectRef>
+          <a:fontRef idx="minor">
+            <a:schemeClr val="lt1"/>
+          </a:fontRef>
+        </p:style>
+        <p:txBody>
+          <a:bodyPr rtlCol="0" anchor="ctr"/>
+          <a:lstStyle/>
+          <a:p>
+            <a:pPr algn="ctr"/>
+          </a:p>
+        </p:txBody>
+      </p:sp>
+      <p:sp>
+        <p:nvSpPr>
+          <p:cNvPr id="42" name="Rounded Rectangle 41"/>
+          <p:cNvSpPr/>
+          <p:nvPr/>
+        </p:nvSpPr>
+        <p:spPr>
+          <a:xfrm>
+            <a:off x="7328916" y="1828800"/>
+            <a:ext cx="2002536" cy="1325880"/>
+          </a:xfrm>
+          <a:prstGeom prst="roundRect">
+            <a:avLst>
+              <a:gd name="adj" fmla="val 16000"/>
+            </a:avLst>
+          </a:prstGeom>
+          <a:solidFill>
+            <a:srgbClr val="0F2A44"/>
+          </a:solidFill>
+          <a:ln>
+            <a:noFill/>
+          </a:ln>
+          <a:effectLst/>
+        </p:spPr>
+        <p:style>
+          <a:lnRef idx="1">
+            <a:schemeClr val="accent1"/>
+          </a:lnRef>
+          <a:fillRef idx="3">
+            <a:schemeClr val="accent1"/>
+          </a:fillRef>
+          <a:effectRef idx="2">
+            <a:schemeClr val="accent1"/>
+          </a:effectRef>
+          <a:fontRef idx="minor">
+            <a:schemeClr val="lt1"/>
+          </a:fontRef>
+        </p:style>
+        <p:txBody>
+          <a:bodyPr rtlCol="0" anchor="ctr"/>
+          <a:lstStyle/>
+          <a:p>
+            <a:pPr algn="ctr"/>
+          </a:p>
+        </p:txBody>
+      </p:sp>
+      <p:sp>
+        <p:nvSpPr>
+          <p:cNvPr id="43" name="Rectangle 42"/>
+          <p:cNvSpPr/>
+          <p:nvPr/>
+        </p:nvSpPr>
+        <p:spPr>
+          <a:xfrm>
+            <a:off x="7328916" y="2788920"/>
+            <a:ext cx="2002536" cy="365760"/>
+          </a:xfrm>
+          <a:prstGeom prst="rect">
+            <a:avLst/>
+          </a:prstGeom>
+          <a:solidFill>
+            <a:srgbClr val="0F2A44"/>
+          </a:solidFill>
+          <a:ln>
+            <a:noFill/>
+          </a:ln>
+          <a:effectLst/>
+        </p:spPr>
+        <p:style>
+          <a:lnRef idx="1">
+            <a:schemeClr val="accent1"/>
+          </a:lnRef>
+          <a:fillRef idx="3">
+            <a:schemeClr val="accent1"/>
+          </a:fillRef>
+          <a:effectRef idx="2">
+            <a:schemeClr val="accent1"/>
+          </a:effectRef>
+          <a:fontRef idx="minor">
+            <a:schemeClr val="lt1"/>
+          </a:fontRef>
+        </p:style>
+        <p:txBody>
+          <a:bodyPr rtlCol="0" anchor="ctr"/>
+          <a:lstStyle/>
+          <a:p>
+            <a:pPr algn="ctr"/>
+          </a:p>
+        </p:txBody>
+      </p:sp>
+      <p:sp>
+        <p:nvSpPr>
+          <p:cNvPr id="44" name="Oval 43"/>
+          <p:cNvSpPr/>
+          <p:nvPr/>
+        </p:nvSpPr>
+        <p:spPr>
+          <a:xfrm>
+            <a:off x="7973568" y="1993392"/>
+            <a:ext cx="713232" cy="713232"/>
+          </a:xfrm>
+          <a:prstGeom prst="ellipse">
+            <a:avLst/>
+          </a:prstGeom>
+          <a:solidFill>
+            <a:srgbClr val="FFFFFF">
+              <a:alpha val="22000"/>
+            </a:srgbClr>
+          </a:solidFill>
+          <a:ln>
+            <a:noFill/>
+          </a:ln>
+          <a:effectLst/>
+        </p:spPr>
+        <p:style>
+          <a:lnRef idx="1">
+            <a:schemeClr val="accent1"/>
+          </a:lnRef>
+          <a:fillRef idx="3">
+            <a:schemeClr val="accent1"/>
+          </a:fillRef>
+          <a:effectRef idx="2">
+            <a:schemeClr val="accent1"/>
+          </a:effectRef>
+          <a:fontRef idx="minor">
+            <a:schemeClr val="lt1"/>
+          </a:fontRef>
+        </p:style>
+        <p:txBody>
+          <a:bodyPr rtlCol="0" anchor="ctr"/>
+          <a:lstStyle/>
+          <a:p>
+            <a:pPr algn="ctr"/>
+          </a:p>
+        </p:txBody>
+      </p:sp>
+      <p:pic>
+        <p:nvPicPr>
+          <p:cNvPr id="45" name="Picture 44" descr="f06e_FFFFFF.png"/>
+          <p:cNvPicPr>
+            <a:picLocks noChangeAspect="1"/>
+          </p:cNvPicPr>
+          <p:nvPr/>
+        </p:nvPicPr>
+        <p:blipFill>
+          <a:blip r:embed="rId5"/>
+          <a:stretch>
+            <a:fillRect/>
+          </a:stretch>
+        </p:blipFill>
+        <p:spPr>
+          <a:xfrm>
+            <a:off x="8110728" y="2130552"/>
+            <a:ext cx="438912" cy="438912"/>
+          </a:xfrm>
+          <a:prstGeom prst="rect">
+            <a:avLst/>
+          </a:prstGeom>
+        </p:spPr>
+      </p:pic>
+      <p:sp>
+        <p:nvSpPr>
+          <p:cNvPr id="46" name="TextBox 45"/>
+          <p:cNvSpPr txBox="1"/>
+          <p:nvPr/>
+        </p:nvSpPr>
+        <p:spPr>
+          <a:xfrm>
+            <a:off x="7420356" y="2743200"/>
+            <a:ext cx="1819656" cy="365760"/>
+          </a:xfrm>
+          <a:prstGeom prst="rect">
+            <a:avLst/>
+          </a:prstGeom>
+          <a:noFill/>
+        </p:spPr>
+        <p:txBody>
+          <a:bodyPr wrap="square" anchor="ctr" lIns="0" rIns="0" tIns="0" bIns="0">
+            <a:spAutoFit/>
+          </a:bodyPr>
+          <a:lstStyle/>
+          <a:p>
+            <a:pPr algn="ctr"/>
+            <a:r>
+              <a:rPr sz="1600" b="1">
+                <a:solidFill>
+                  <a:srgbClr val="FFFFFF"/>
+                </a:solidFill>
+                <a:latin typeface="Poppins"/>
+              </a:rPr>
+              <a:t>Art. 11</a:t>
+            </a:r>
+          </a:p>
+        </p:txBody>
+      </p:sp>
+      <p:sp>
+        <p:nvSpPr>
+          <p:cNvPr id="47" name="TextBox 46"/>
+          <p:cNvSpPr txBox="1"/>
+          <p:nvPr/>
+        </p:nvSpPr>
+        <p:spPr>
+          <a:xfrm>
+            <a:off x="7511796" y="3337560"/>
+            <a:ext cx="1636776" cy="960120"/>
+          </a:xfrm>
+          <a:prstGeom prst="rect">
+            <a:avLst/>
+          </a:prstGeom>
+          <a:noFill/>
+        </p:spPr>
+        <p:txBody>
+          <a:bodyPr wrap="square" anchor="ctr" lIns="0" rIns="0" tIns="0" bIns="0">
+            <a:spAutoFit/>
+          </a:bodyPr>
+          <a:lstStyle/>
+          <a:p>
+            <a:pPr algn="ctr">
+              <a:lnSpc>
+                <a:spcPct val="100000"/>
+              </a:lnSpc>
+            </a:pPr>
+            <a:r>
+              <a:rPr sz="1600" b="1">
+                <a:solidFill>
+                  <a:srgbClr val="0F2A44"/>
+                </a:solidFill>
+                <a:latin typeface="Poppins"/>
+              </a:rPr>
+              <a:t>Monitoreo sin revisar el celular</a:t>
+            </a:r>
+          </a:p>
+        </p:txBody>
+      </p:sp>
+      <p:sp>
+        <p:nvSpPr>
+          <p:cNvPr id="48" name="Down Arrow 47"/>
+          <p:cNvSpPr/>
+          <p:nvPr/>
+        </p:nvSpPr>
+        <p:spPr>
+          <a:xfrm>
+            <a:off x="8138160" y="4407408"/>
+            <a:ext cx="384048" cy="274320"/>
+          </a:xfrm>
+          <a:prstGeom prst="downArrow">
+            <a:avLst/>
+          </a:prstGeom>
+          <a:solidFill>
+            <a:srgbClr val="E0A526"/>
+          </a:solidFill>
+          <a:ln>
+            <a:noFill/>
+          </a:ln>
+          <a:effectLst/>
+        </p:spPr>
+        <p:style>
+          <a:lnRef idx="1">
+            <a:schemeClr val="accent1"/>
+          </a:lnRef>
+          <a:fillRef idx="3">
+            <a:schemeClr val="accent1"/>
+          </a:fillRef>
+          <a:effectRef idx="2">
+            <a:schemeClr val="accent1"/>
+          </a:effectRef>
+          <a:fontRef idx="minor">
+            <a:schemeClr val="lt1"/>
+          </a:fontRef>
+        </p:style>
+        <p:txBody>
+          <a:bodyPr rtlCol="0" anchor="ctr"/>
+          <a:lstStyle/>
+          <a:p>
+            <a:pPr algn="ctr"/>
+          </a:p>
+        </p:txBody>
+      </p:sp>
+      <p:sp>
+        <p:nvSpPr>
+          <p:cNvPr id="49" name="TextBox 48"/>
+          <p:cNvSpPr txBox="1"/>
+          <p:nvPr/>
+        </p:nvSpPr>
+        <p:spPr>
+          <a:xfrm>
+            <a:off x="7420356" y="4754880"/>
+            <a:ext cx="1819656" cy="274320"/>
+          </a:xfrm>
+          <a:prstGeom prst="rect">
+            <a:avLst/>
+          </a:prstGeom>
+          <a:noFill/>
+        </p:spPr>
+        <p:txBody>
+          <a:bodyPr wrap="square" anchor="t" lIns="0" rIns="0" tIns="0" bIns="0">
+            <a:spAutoFit/>
+          </a:bodyPr>
+          <a:lstStyle/>
+          <a:p>
+            <a:pPr algn="ctr"/>
+            <a:r>
+              <a:rPr sz="1100" b="1">
+                <a:solidFill>
+                  <a:srgbClr val="5B6775"/>
+                </a:solidFill>
+                <a:latin typeface="Poppins"/>
+              </a:rPr>
+              <a:t>EN NUESTRO RI</a:t>
+            </a:r>
+          </a:p>
+        </p:txBody>
+      </p:sp>
+      <p:sp>
+        <p:nvSpPr>
+          <p:cNvPr id="50" name="Rounded Rectangle 49"/>
+          <p:cNvSpPr/>
+          <p:nvPr/>
+        </p:nvSpPr>
+        <p:spPr>
+          <a:xfrm>
+            <a:off x="7466076" y="5047488"/>
+            <a:ext cx="1728216" cy="941832"/>
+          </a:xfrm>
+          <a:prstGeom prst="roundRect">
+            <a:avLst>
+              <a:gd name="adj" fmla="val 14000"/>
+            </a:avLst>
+          </a:prstGeom>
+          <a:solidFill>
+            <a:srgbClr val="E6EEEE"/>
+          </a:solidFill>
+          <a:ln>
+            <a:noFill/>
+          </a:ln>
+          <a:effectLst/>
+        </p:spPr>
+        <p:style>
+          <a:lnRef idx="1">
+            <a:schemeClr val="accent1"/>
+          </a:lnRef>
+          <a:fillRef idx="3">
+            <a:schemeClr val="accent1"/>
+          </a:fillRef>
+          <a:effectRef idx="2">
+            <a:schemeClr val="accent1"/>
+          </a:effectRef>
+          <a:fontRef idx="minor">
+            <a:schemeClr val="lt1"/>
+          </a:fontRef>
+        </p:style>
+        <p:txBody>
+          <a:bodyPr rtlCol="0" anchor="ctr"/>
+          <a:lstStyle/>
+          <a:p>
+            <a:pPr algn="ctr"/>
+          </a:p>
+        </p:txBody>
+      </p:sp>
+      <p:sp>
+        <p:nvSpPr>
+          <p:cNvPr id="51" name="TextBox 50"/>
+          <p:cNvSpPr txBox="1"/>
+          <p:nvPr/>
+        </p:nvSpPr>
+        <p:spPr>
+          <a:xfrm>
+            <a:off x="7511796" y="5093208"/>
+            <a:ext cx="1636776" cy="438912"/>
+          </a:xfrm>
+          <a:prstGeom prst="rect">
+            <a:avLst/>
+          </a:prstGeom>
+          <a:noFill/>
+        </p:spPr>
+        <p:txBody>
+          <a:bodyPr wrap="square" anchor="ctr" lIns="0" rIns="0" tIns="0" bIns="0">
+            <a:spAutoFit/>
+          </a:bodyPr>
+          <a:lstStyle/>
+          <a:p>
+            <a:pPr algn="ctr"/>
+            <a:r>
+              <a:rPr sz="1700" b="1">
+                <a:solidFill>
+                  <a:srgbClr val="0F2A44"/>
+                </a:solidFill>
+                <a:latin typeface="Poppins"/>
+              </a:rPr>
+              <a:t>Art. 69°</a:t>
+            </a:r>
+          </a:p>
+        </p:txBody>
+      </p:sp>
+      <p:sp>
+        <p:nvSpPr>
+          <p:cNvPr id="52" name="TextBox 51"/>
+          <p:cNvSpPr txBox="1"/>
+          <p:nvPr/>
+        </p:nvSpPr>
+        <p:spPr>
+          <a:xfrm>
+            <a:off x="7511796" y="5513832"/>
+            <a:ext cx="1636776" cy="429768"/>
+          </a:xfrm>
+          <a:prstGeom prst="rect">
+            <a:avLst/>
+          </a:prstGeom>
+          <a:noFill/>
+        </p:spPr>
+        <p:txBody>
+          <a:bodyPr wrap="square" anchor="ctr" lIns="0" rIns="0" tIns="0" bIns="0">
+            <a:spAutoFit/>
+          </a:bodyPr>
+          <a:lstStyle/>
+          <a:p>
+            <a:pPr algn="ctr">
+              <a:lnSpc>
+                <a:spcPct val="95000"/>
+              </a:lnSpc>
+            </a:pPr>
+            <a:r>
+              <a:rPr sz="1100" b="0">
+                <a:solidFill>
+                  <a:srgbClr val="1F2A37"/>
+                </a:solidFill>
+                <a:latin typeface="Poppins"/>
+              </a:rPr>
+              <a:t>Tít. III · Cap. X · Clima · SISEVE</a:t>
+            </a:r>
+          </a:p>
+        </p:txBody>
+      </p:sp>
+      <p:sp>
+        <p:nvSpPr>
+          <p:cNvPr id="53" name="Rounded Rectangle 52"/>
+          <p:cNvSpPr/>
+          <p:nvPr/>
+        </p:nvSpPr>
+        <p:spPr>
+          <a:xfrm>
+            <a:off x="9528048" y="1828800"/>
+            <a:ext cx="2002536" cy="4343400"/>
+          </a:xfrm>
+          <a:prstGeom prst="roundRect">
+            <a:avLst>
+              <a:gd name="adj" fmla="val 7000"/>
+            </a:avLst>
+          </a:prstGeom>
+          <a:solidFill>
+            <a:srgbClr val="FFFFFF"/>
+          </a:solidFill>
+          <a:ln>
+            <a:noFill/>
+          </a:ln>
+          <a:effectLst/>
+        </p:spPr>
+        <p:style>
+          <a:lnRef idx="1">
+            <a:schemeClr val="accent1"/>
+          </a:lnRef>
+          <a:fillRef idx="3">
+            <a:schemeClr val="accent1"/>
+          </a:fillRef>
+          <a:effectRef idx="2">
+            <a:schemeClr val="accent1"/>
+          </a:effectRef>
+          <a:fontRef idx="minor">
+            <a:schemeClr val="lt1"/>
+          </a:fontRef>
+        </p:style>
+        <p:txBody>
+          <a:bodyPr rtlCol="0" anchor="ctr"/>
+          <a:lstStyle/>
+          <a:p>
+            <a:pPr algn="ctr"/>
+          </a:p>
+        </p:txBody>
+      </p:sp>
+      <p:sp>
+        <p:nvSpPr>
+          <p:cNvPr id="54" name="Rounded Rectangle 53"/>
+          <p:cNvSpPr/>
+          <p:nvPr/>
+        </p:nvSpPr>
+        <p:spPr>
+          <a:xfrm>
+            <a:off x="9528048" y="1828800"/>
+            <a:ext cx="2002536" cy="1325880"/>
+          </a:xfrm>
+          <a:prstGeom prst="roundRect">
+            <a:avLst>
+              <a:gd name="adj" fmla="val 16000"/>
+            </a:avLst>
+          </a:prstGeom>
+          <a:solidFill>
+            <a:srgbClr val="0F2A44"/>
+          </a:solidFill>
+          <a:ln>
+            <a:noFill/>
+          </a:ln>
+          <a:effectLst/>
+        </p:spPr>
+        <p:style>
+          <a:lnRef idx="1">
+            <a:schemeClr val="accent1"/>
+          </a:lnRef>
+          <a:fillRef idx="3">
+            <a:schemeClr val="accent1"/>
+          </a:fillRef>
+          <a:effectRef idx="2">
+            <a:schemeClr val="accent1"/>
+          </a:effectRef>
+          <a:fontRef idx="minor">
+            <a:schemeClr val="lt1"/>
+          </a:fontRef>
+        </p:style>
+        <p:txBody>
+          <a:bodyPr rtlCol="0" anchor="ctr"/>
+          <a:lstStyle/>
+          <a:p>
+            <a:pPr algn="ctr"/>
+          </a:p>
+        </p:txBody>
+      </p:sp>
+      <p:sp>
+        <p:nvSpPr>
+          <p:cNvPr id="55" name="Rectangle 54"/>
+          <p:cNvSpPr/>
+          <p:nvPr/>
+        </p:nvSpPr>
+        <p:spPr>
+          <a:xfrm>
+            <a:off x="9528048" y="2788920"/>
+            <a:ext cx="2002536" cy="365760"/>
+          </a:xfrm>
+          <a:prstGeom prst="rect">
+            <a:avLst/>
+          </a:prstGeom>
+          <a:solidFill>
+            <a:srgbClr val="0F2A44"/>
+          </a:solidFill>
+          <a:ln>
+            <a:noFill/>
+          </a:ln>
+          <a:effectLst/>
+        </p:spPr>
+        <p:style>
+          <a:lnRef idx="1">
+            <a:schemeClr val="accent1"/>
+          </a:lnRef>
+          <a:fillRef idx="3">
+            <a:schemeClr val="accent1"/>
+          </a:fillRef>
+          <a:effectRef idx="2">
+            <a:schemeClr val="accent1"/>
+          </a:effectRef>
+          <a:fontRef idx="minor">
+            <a:schemeClr val="lt1"/>
+          </a:fontRef>
+        </p:style>
+        <p:txBody>
+          <a:bodyPr rtlCol="0" anchor="ctr"/>
+          <a:lstStyle/>
+          <a:p>
+            <a:pPr algn="ctr"/>
+          </a:p>
+        </p:txBody>
+      </p:sp>
+      <p:sp>
+        <p:nvSpPr>
+          <p:cNvPr id="56" name="Oval 55"/>
+          <p:cNvSpPr/>
+          <p:nvPr/>
+        </p:nvSpPr>
+        <p:spPr>
+          <a:xfrm>
+            <a:off x="10172700" y="1993392"/>
+            <a:ext cx="713232" cy="713232"/>
+          </a:xfrm>
+          <a:prstGeom prst="ellipse">
+            <a:avLst/>
+          </a:prstGeom>
+          <a:solidFill>
+            <a:srgbClr val="FFFFFF">
+              <a:alpha val="22000"/>
+            </a:srgbClr>
+          </a:solidFill>
+          <a:ln>
+            <a:noFill/>
+          </a:ln>
+          <a:effectLst/>
+        </p:spPr>
+        <p:style>
+          <a:lnRef idx="1">
+            <a:schemeClr val="accent1"/>
+          </a:lnRef>
+          <a:fillRef idx="3">
+            <a:schemeClr val="accent1"/>
+          </a:fillRef>
+          <a:effectRef idx="2">
+            <a:schemeClr val="accent1"/>
+          </a:effectRef>
+          <a:fontRef idx="minor">
+            <a:schemeClr val="lt1"/>
+          </a:fontRef>
+        </p:style>
+        <p:txBody>
+          <a:bodyPr rtlCol="0" anchor="ctr"/>
+          <a:lstStyle/>
+          <a:p>
+            <a:pPr algn="ctr"/>
+          </a:p>
+        </p:txBody>
+      </p:sp>
+      <p:pic>
+        <p:nvPicPr>
+          <p:cNvPr id="57" name="Picture 56" descr="f24e_FFFFFF.png"/>
+          <p:cNvPicPr>
+            <a:picLocks noChangeAspect="1"/>
+          </p:cNvPicPr>
+          <p:nvPr/>
+        </p:nvPicPr>
+        <p:blipFill>
+          <a:blip r:embed="rId6"/>
+          <a:stretch>
+            <a:fillRect/>
+          </a:stretch>
+        </p:blipFill>
+        <p:spPr>
+          <a:xfrm>
+            <a:off x="10309860" y="2130552"/>
+            <a:ext cx="438912" cy="438912"/>
+          </a:xfrm>
+          <a:prstGeom prst="rect">
+            <a:avLst/>
+          </a:prstGeom>
+        </p:spPr>
+      </p:pic>
+      <p:sp>
+        <p:nvSpPr>
+          <p:cNvPr id="58" name="TextBox 57"/>
+          <p:cNvSpPr txBox="1"/>
+          <p:nvPr/>
+        </p:nvSpPr>
+        <p:spPr>
+          <a:xfrm>
+            <a:off x="9619488" y="2743200"/>
+            <a:ext cx="1819656" cy="365760"/>
+          </a:xfrm>
+          <a:prstGeom prst="rect">
+            <a:avLst/>
+          </a:prstGeom>
+          <a:noFill/>
+        </p:spPr>
+        <p:txBody>
+          <a:bodyPr wrap="square" anchor="ctr" lIns="0" rIns="0" tIns="0" bIns="0">
+            <a:spAutoFit/>
+          </a:bodyPr>
+          <a:lstStyle/>
+          <a:p>
+            <a:pPr algn="ctr"/>
+            <a:r>
+              <a:rPr sz="1600" b="1">
+                <a:solidFill>
+                  <a:srgbClr val="FFFFFF"/>
+                </a:solidFill>
+                <a:latin typeface="Poppins"/>
+              </a:rPr>
+              <a:t>Art. 12</a:t>
+            </a:r>
+          </a:p>
+        </p:txBody>
+      </p:sp>
+      <p:sp>
+        <p:nvSpPr>
+          <p:cNvPr id="59" name="TextBox 58"/>
+          <p:cNvSpPr txBox="1"/>
+          <p:nvPr/>
+        </p:nvSpPr>
+        <p:spPr>
+          <a:xfrm>
+            <a:off x="9710928" y="3337560"/>
+            <a:ext cx="1636776" cy="960120"/>
+          </a:xfrm>
+          <a:prstGeom prst="rect">
+            <a:avLst/>
+          </a:prstGeom>
+          <a:noFill/>
+        </p:spPr>
+        <p:txBody>
+          <a:bodyPr wrap="square" anchor="ctr" lIns="0" rIns="0" tIns="0" bIns="0">
+            <a:spAutoFit/>
+          </a:bodyPr>
+          <a:lstStyle/>
+          <a:p>
+            <a:pPr algn="ctr">
+              <a:lnSpc>
+                <a:spcPct val="100000"/>
+              </a:lnSpc>
+            </a:pPr>
+            <a:r>
+              <a:rPr sz="1600" b="1">
+                <a:solidFill>
+                  <a:srgbClr val="0F2A44"/>
+                </a:solidFill>
+                <a:latin typeface="Poppins"/>
+              </a:rPr>
+              <a:t>Medidas formativas y graduales</a:t>
+            </a:r>
+          </a:p>
+        </p:txBody>
+      </p:sp>
+      <p:sp>
+        <p:nvSpPr>
+          <p:cNvPr id="60" name="Down Arrow 59"/>
+          <p:cNvSpPr/>
+          <p:nvPr/>
+        </p:nvSpPr>
+        <p:spPr>
+          <a:xfrm>
+            <a:off x="10337292" y="4407408"/>
+            <a:ext cx="384048" cy="274320"/>
+          </a:xfrm>
+          <a:prstGeom prst="downArrow">
+            <a:avLst/>
+          </a:prstGeom>
+          <a:solidFill>
+            <a:srgbClr val="E0A526"/>
+          </a:solidFill>
+          <a:ln>
+            <a:noFill/>
+          </a:ln>
+          <a:effectLst/>
+        </p:spPr>
+        <p:style>
+          <a:lnRef idx="1">
+            <a:schemeClr val="accent1"/>
+          </a:lnRef>
+          <a:fillRef idx="3">
+            <a:schemeClr val="accent1"/>
+          </a:fillRef>
+          <a:effectRef idx="2">
+            <a:schemeClr val="accent1"/>
+          </a:effectRef>
+          <a:fontRef idx="minor">
+            <a:schemeClr val="lt1"/>
+          </a:fontRef>
+        </p:style>
+        <p:txBody>
+          <a:bodyPr rtlCol="0" anchor="ctr"/>
+          <a:lstStyle/>
+          <a:p>
+            <a:pPr algn="ctr"/>
+          </a:p>
+        </p:txBody>
+      </p:sp>
+      <p:sp>
+        <p:nvSpPr>
+          <p:cNvPr id="61" name="TextBox 60"/>
+          <p:cNvSpPr txBox="1"/>
+          <p:nvPr/>
+        </p:nvSpPr>
+        <p:spPr>
+          <a:xfrm>
+            <a:off x="9619488" y="4754880"/>
+            <a:ext cx="1819656" cy="274320"/>
+          </a:xfrm>
+          <a:prstGeom prst="rect">
+            <a:avLst/>
+          </a:prstGeom>
+          <a:noFill/>
+        </p:spPr>
+        <p:txBody>
+          <a:bodyPr wrap="square" anchor="t" lIns="0" rIns="0" tIns="0" bIns="0">
+            <a:spAutoFit/>
+          </a:bodyPr>
+          <a:lstStyle/>
+          <a:p>
+            <a:pPr algn="ctr"/>
+            <a:r>
+              <a:rPr sz="1100" b="1">
+                <a:solidFill>
+                  <a:srgbClr val="5B6775"/>
+                </a:solidFill>
+                <a:latin typeface="Poppins"/>
+              </a:rPr>
+              <a:t>EN NUESTRO RI</a:t>
+            </a:r>
+          </a:p>
+        </p:txBody>
+      </p:sp>
+      <p:sp>
+        <p:nvSpPr>
+          <p:cNvPr id="62" name="Rounded Rectangle 61"/>
+          <p:cNvSpPr/>
+          <p:nvPr/>
+        </p:nvSpPr>
+        <p:spPr>
+          <a:xfrm>
+            <a:off x="9665208" y="5047488"/>
+            <a:ext cx="1728216" cy="941832"/>
+          </a:xfrm>
+          <a:prstGeom prst="roundRect">
+            <a:avLst>
+              <a:gd name="adj" fmla="val 14000"/>
+            </a:avLst>
+          </a:prstGeom>
+          <a:solidFill>
+            <a:srgbClr val="E6EEEE"/>
+          </a:solidFill>
+          <a:ln>
+            <a:noFill/>
+          </a:ln>
+          <a:effectLst/>
+        </p:spPr>
+        <p:style>
+          <a:lnRef idx="1">
+            <a:schemeClr val="accent1"/>
+          </a:lnRef>
+          <a:fillRef idx="3">
+            <a:schemeClr val="accent1"/>
+          </a:fillRef>
+          <a:effectRef idx="2">
+            <a:schemeClr val="accent1"/>
+          </a:effectRef>
+          <a:fontRef idx="minor">
+            <a:schemeClr val="lt1"/>
+          </a:fontRef>
+        </p:style>
+        <p:txBody>
+          <a:bodyPr rtlCol="0" anchor="ctr"/>
+          <a:lstStyle/>
+          <a:p>
+            <a:pPr algn="ctr"/>
+          </a:p>
+        </p:txBody>
+      </p:sp>
+      <p:sp>
+        <p:nvSpPr>
+          <p:cNvPr id="63" name="TextBox 62"/>
+          <p:cNvSpPr txBox="1"/>
+          <p:nvPr/>
+        </p:nvSpPr>
+        <p:spPr>
+          <a:xfrm>
+            <a:off x="9710928" y="5093208"/>
+            <a:ext cx="1636776" cy="438912"/>
+          </a:xfrm>
+          <a:prstGeom prst="rect">
+            <a:avLst/>
+          </a:prstGeom>
+          <a:noFill/>
+        </p:spPr>
+        <p:txBody>
+          <a:bodyPr wrap="square" anchor="ctr" lIns="0" rIns="0" tIns="0" bIns="0">
+            <a:spAutoFit/>
+          </a:bodyPr>
+          <a:lstStyle/>
+          <a:p>
+            <a:pPr algn="ctr"/>
+            <a:r>
+              <a:rPr sz="1700" b="1">
+                <a:solidFill>
+                  <a:srgbClr val="0F2A44"/>
+                </a:solidFill>
+                <a:latin typeface="Poppins"/>
+              </a:rPr>
+              <a:t>Arts. 141°–145°</a:t>
+            </a:r>
+          </a:p>
+        </p:txBody>
+      </p:sp>
+      <p:sp>
+        <p:nvSpPr>
+          <p:cNvPr id="64" name="TextBox 63"/>
+          <p:cNvSpPr txBox="1"/>
+          <p:nvPr/>
+        </p:nvSpPr>
+        <p:spPr>
+          <a:xfrm>
+            <a:off x="9710928" y="5513832"/>
+            <a:ext cx="1636776" cy="429768"/>
+          </a:xfrm>
+          <a:prstGeom prst="rect">
+            <a:avLst/>
+          </a:prstGeom>
+          <a:noFill/>
+        </p:spPr>
+        <p:txBody>
+          <a:bodyPr wrap="square" anchor="ctr" lIns="0" rIns="0" tIns="0" bIns="0">
+            <a:spAutoFit/>
+          </a:bodyPr>
+          <a:lstStyle/>
+          <a:p>
+            <a:pPr algn="ctr">
+              <a:lnSpc>
+                <a:spcPct val="95000"/>
+              </a:lnSpc>
+            </a:pPr>
+            <a:r>
+              <a:rPr sz="1100" b="0">
+                <a:solidFill>
+                  <a:srgbClr val="1F2A37"/>
+                </a:solidFill>
+                <a:latin typeface="Poppins"/>
+              </a:rPr>
+              <a:t>Tít. V · Faltas y medidas</a:t>
+            </a:r>
+          </a:p>
+        </p:txBody>
+      </p:sp>
+      <p:sp>
+        <p:nvSpPr>
+          <p:cNvPr id="65" name="TextBox 64"/>
+          <p:cNvSpPr txBox="1"/>
+          <p:nvPr/>
+        </p:nvSpPr>
+        <p:spPr>
+          <a:xfrm>
+            <a:off x="731520" y="6419088"/>
+            <a:ext cx="10789920" cy="274320"/>
+          </a:xfrm>
+          <a:prstGeom prst="rect">
+            <a:avLst/>
+          </a:prstGeom>
+          <a:noFill/>
+        </p:spPr>
+        <p:txBody>
+          <a:bodyPr wrap="square" anchor="t" lIns="0" rIns="0" tIns="0" bIns="0">
+            <a:spAutoFit/>
+          </a:bodyPr>
+          <a:lstStyle/>
+          <a:p>
+            <a:pPr algn="l"/>
+            <a:r>
+              <a:rPr sz="1000" b="0">
+                <a:solidFill>
+                  <a:srgbClr val="5B6775"/>
+                </a:solidFill>
+                <a:latin typeface="Poppins"/>
+              </a:rPr>
+              <a:t>Reglamento de la Ley N.º 32385  ·  RI I.E.S. JEC “Rosaspata” (R.D. N.º 012-2026)  ·  GRUPO NATALIO</a:t>
+            </a:r>
+          </a:p>
+        </p:txBody>
+      </p:sp>
+    </p:spTree>
+  </p:cSld>
+  <p:clrMapOvr>
+    <a:masterClrMapping/>
+  </p:clrMapOvr>
+</p:sld>
+</file>
+
+<file path=ppt/slides/slide9.xml><?xml version="1.0" encoding="utf-8"?>
 <p:sld xmlns:a="http://schemas.openxmlformats.org/drawingml/2006/main" xmlns:p="http://schemas.openxmlformats.org/presentationml/2006/main" xmlns:r="http://schemas.openxmlformats.org/officeDocument/2006/relationships">
   <p:cSld>
     <p:spTree>

</xml_diff>

<commit_message>
Portada: foto caricaturizada (filtro OpenCV) del Presidente · Grupo Natalio
</commit_message>
<xml_diff>
--- a/Grupo_Natalio_Articulos_9_13.pptx
+++ b/Grupo_Natalio_Articulos_9_13.pptx
@@ -4710,6 +4710,155 @@
                 <a:latin typeface="Poppins"/>
               </a:rPr>
               <a:t>Puno, 2026</a:t>
+            </a:r>
+          </a:p>
+        </p:txBody>
+      </p:sp>
+      <p:sp>
+        <p:nvSpPr>
+          <p:cNvPr id="18" name="Oval 17"/>
+          <p:cNvSpPr/>
+          <p:nvPr/>
+        </p:nvSpPr>
+        <p:spPr>
+          <a:xfrm>
+            <a:off x="8394192" y="1143000"/>
+            <a:ext cx="3200400" cy="3200400"/>
+          </a:xfrm>
+          <a:prstGeom prst="ellipse">
+            <a:avLst/>
+          </a:prstGeom>
+          <a:solidFill>
+            <a:srgbClr val="E0A526"/>
+          </a:solidFill>
+          <a:ln>
+            <a:noFill/>
+          </a:ln>
+          <a:effectLst/>
+        </p:spPr>
+        <p:style>
+          <a:lnRef idx="1">
+            <a:schemeClr val="accent1"/>
+          </a:lnRef>
+          <a:fillRef idx="3">
+            <a:schemeClr val="accent1"/>
+          </a:fillRef>
+          <a:effectRef idx="2">
+            <a:schemeClr val="accent1"/>
+          </a:effectRef>
+          <a:fontRef idx="minor">
+            <a:schemeClr val="lt1"/>
+          </a:fontRef>
+        </p:style>
+        <p:txBody>
+          <a:bodyPr rtlCol="0" anchor="ctr"/>
+          <a:lstStyle/>
+          <a:p>
+            <a:pPr algn="ctr"/>
+          </a:p>
+        </p:txBody>
+      </p:sp>
+      <p:pic>
+        <p:nvPicPr>
+          <p:cNvPr id="19" name="Picture 18" descr="pres_round.png"/>
+          <p:cNvPicPr>
+            <a:picLocks noChangeAspect="1"/>
+          </p:cNvPicPr>
+          <p:nvPr/>
+        </p:nvPicPr>
+        <p:blipFill>
+          <a:blip r:embed="rId3"/>
+          <a:stretch>
+            <a:fillRect/>
+          </a:stretch>
+        </p:blipFill>
+        <p:spPr>
+          <a:xfrm>
+            <a:off x="8503920" y="1252728"/>
+            <a:ext cx="2980944" cy="2980944"/>
+          </a:xfrm>
+          <a:prstGeom prst="rect">
+            <a:avLst/>
+          </a:prstGeom>
+        </p:spPr>
+      </p:pic>
+      <p:sp>
+        <p:nvSpPr>
+          <p:cNvPr id="20" name="Rounded Rectangle 19"/>
+          <p:cNvSpPr/>
+          <p:nvPr/>
+        </p:nvSpPr>
+        <p:spPr>
+          <a:xfrm>
+            <a:off x="8211312" y="4553712"/>
+            <a:ext cx="3566160" cy="548640"/>
+          </a:xfrm>
+          <a:prstGeom prst="roundRect">
+            <a:avLst>
+              <a:gd name="adj" fmla="val 50000"/>
+            </a:avLst>
+          </a:prstGeom>
+          <a:solidFill>
+            <a:srgbClr val="E0A526"/>
+          </a:solidFill>
+          <a:ln>
+            <a:noFill/>
+          </a:ln>
+          <a:effectLst/>
+        </p:spPr>
+        <p:style>
+          <a:lnRef idx="1">
+            <a:schemeClr val="accent1"/>
+          </a:lnRef>
+          <a:fillRef idx="3">
+            <a:schemeClr val="accent1"/>
+          </a:fillRef>
+          <a:effectRef idx="2">
+            <a:schemeClr val="accent1"/>
+          </a:effectRef>
+          <a:fontRef idx="minor">
+            <a:schemeClr val="lt1"/>
+          </a:fontRef>
+        </p:style>
+        <p:txBody>
+          <a:bodyPr rtlCol="0" anchor="ctr"/>
+          <a:lstStyle/>
+          <a:p>
+            <a:pPr algn="ctr"/>
+          </a:p>
+        </p:txBody>
+      </p:sp>
+      <p:sp>
+        <p:nvSpPr>
+          <p:cNvPr id="21" name="TextBox 20"/>
+          <p:cNvSpPr txBox="1"/>
+          <p:nvPr/>
+        </p:nvSpPr>
+        <p:spPr>
+          <a:xfrm>
+            <a:off x="8211312" y="4553712"/>
+            <a:ext cx="3566160" cy="548640"/>
+          </a:xfrm>
+          <a:prstGeom prst="rect">
+            <a:avLst/>
+          </a:prstGeom>
+          <a:noFill/>
+        </p:spPr>
+        <p:txBody>
+          <a:bodyPr wrap="square" anchor="ctr" lIns="0" rIns="0" tIns="0" bIns="0">
+            <a:spAutoFit/>
+          </a:bodyPr>
+          <a:lstStyle/>
+          <a:p>
+            <a:pPr algn="ctr"/>
+            <a:r>
+              <a:rPr sz="1700" b="1">
+                <a:solidFill>
+                  <a:srgbClr val="0F2A44"/>
+                </a:solidFill>
+                <a:latin typeface="Poppins"/>
+              </a:rPr>
+              <a:t>Presidente · Grupo Natalio</a:t>
             </a:r>
           </a:p>
         </p:txBody>

</xml_diff>

<commit_message>
Diapositiva 4 (Art. 10): sticker caricatura futbolista 'Carrillo · artículo 10'
</commit_message>
<xml_diff>
--- a/Grupo_Natalio_Articulos_9_13.pptx
+++ b/Grupo_Natalio_Articulos_9_13.pptx
@@ -8998,6 +8998,159 @@
                 <a:latin typeface="Poppins"/>
               </a:rPr>
               <a:t>Reglamento de la Ley N.º 32385  ·  GRUPO NATALIO</a:t>
+            </a:r>
+          </a:p>
+        </p:txBody>
+      </p:sp>
+      <p:sp>
+        <p:nvSpPr>
+          <p:cNvPr id="35" name="Rounded Rectangle 34"/>
+          <p:cNvSpPr/>
+          <p:nvPr/>
+        </p:nvSpPr>
+        <p:spPr>
+          <a:xfrm>
+            <a:off x="292608" y="292608"/>
+            <a:ext cx="1737360" cy="2606040"/>
+          </a:xfrm>
+          <a:prstGeom prst="roundRect">
+            <a:avLst>
+              <a:gd name="adj" fmla="val 10000"/>
+            </a:avLst>
+          </a:prstGeom>
+          <a:solidFill>
+            <a:srgbClr val="FFFFFF"/>
+          </a:solidFill>
+          <a:ln w="15875">
+            <a:solidFill>
+              <a:srgbClr val="E0A526"/>
+            </a:solidFill>
+          </a:ln>
+          <a:effectLst/>
+        </p:spPr>
+        <p:style>
+          <a:lnRef idx="1">
+            <a:schemeClr val="accent1"/>
+          </a:lnRef>
+          <a:fillRef idx="3">
+            <a:schemeClr val="accent1"/>
+          </a:fillRef>
+          <a:effectRef idx="2">
+            <a:schemeClr val="accent1"/>
+          </a:effectRef>
+          <a:fontRef idx="minor">
+            <a:schemeClr val="lt1"/>
+          </a:fontRef>
+        </p:style>
+        <p:txBody>
+          <a:bodyPr rtlCol="0" anchor="ctr"/>
+          <a:lstStyle/>
+          <a:p>
+            <a:pPr algn="ctr"/>
+          </a:p>
+        </p:txBody>
+      </p:sp>
+      <p:pic>
+        <p:nvPicPr>
+          <p:cNvPr id="36" name="Picture 35" descr="futbolista_crop.png"/>
+          <p:cNvPicPr>
+            <a:picLocks noChangeAspect="1"/>
+          </p:cNvPicPr>
+          <p:nvPr/>
+        </p:nvPicPr>
+        <p:blipFill>
+          <a:blip r:embed="rId7"/>
+          <a:stretch>
+            <a:fillRect/>
+          </a:stretch>
+        </p:blipFill>
+        <p:spPr>
+          <a:xfrm>
+            <a:off x="384048" y="365760"/>
+            <a:ext cx="1554480" cy="1920240"/>
+          </a:xfrm>
+          <a:prstGeom prst="rect">
+            <a:avLst/>
+          </a:prstGeom>
+        </p:spPr>
+      </p:pic>
+      <p:sp>
+        <p:nvSpPr>
+          <p:cNvPr id="37" name="Rounded Rectangle 36"/>
+          <p:cNvSpPr/>
+          <p:nvPr/>
+        </p:nvSpPr>
+        <p:spPr>
+          <a:xfrm>
+            <a:off x="384048" y="2377440"/>
+            <a:ext cx="1554480" cy="411480"/>
+          </a:xfrm>
+          <a:prstGeom prst="roundRect">
+            <a:avLst>
+              <a:gd name="adj" fmla="val 50000"/>
+            </a:avLst>
+          </a:prstGeom>
+          <a:solidFill>
+            <a:srgbClr val="E0A526"/>
+          </a:solidFill>
+          <a:ln>
+            <a:noFill/>
+          </a:ln>
+          <a:effectLst/>
+        </p:spPr>
+        <p:style>
+          <a:lnRef idx="1">
+            <a:schemeClr val="accent1"/>
+          </a:lnRef>
+          <a:fillRef idx="3">
+            <a:schemeClr val="accent1"/>
+          </a:fillRef>
+          <a:effectRef idx="2">
+            <a:schemeClr val="accent1"/>
+          </a:effectRef>
+          <a:fontRef idx="minor">
+            <a:schemeClr val="lt1"/>
+          </a:fontRef>
+        </p:style>
+        <p:txBody>
+          <a:bodyPr rtlCol="0" anchor="ctr"/>
+          <a:lstStyle/>
+          <a:p>
+            <a:pPr algn="ctr"/>
+          </a:p>
+        </p:txBody>
+      </p:sp>
+      <p:sp>
+        <p:nvSpPr>
+          <p:cNvPr id="38" name="TextBox 37"/>
+          <p:cNvSpPr txBox="1"/>
+          <p:nvPr/>
+        </p:nvSpPr>
+        <p:spPr>
+          <a:xfrm>
+            <a:off x="384048" y="2377440"/>
+            <a:ext cx="1554480" cy="411480"/>
+          </a:xfrm>
+          <a:prstGeom prst="rect">
+            <a:avLst/>
+          </a:prstGeom>
+          <a:noFill/>
+        </p:spPr>
+        <p:txBody>
+          <a:bodyPr wrap="square" anchor="ctr" lIns="0" rIns="0" tIns="0" bIns="0">
+            <a:spAutoFit/>
+          </a:bodyPr>
+          <a:lstStyle/>
+          <a:p>
+            <a:pPr algn="ctr"/>
+            <a:r>
+              <a:rPr sz="1100" b="1">
+                <a:solidFill>
+                  <a:srgbClr val="0F2A44"/>
+                </a:solidFill>
+                <a:latin typeface="Poppins"/>
+              </a:rPr>
+              <a:t>Carrillo · artículo 10</a:t>
             </a:r>
           </a:p>
         </p:txBody>

</xml_diff>

<commit_message>
Diapositiva final: retrato del Presidente y sticker de Carrillo
</commit_message>
<xml_diff>
--- a/Grupo_Natalio_Articulos_9_13.pptx
+++ b/Grupo_Natalio_Articulos_9_13.pptx
@@ -16411,6 +16411,308 @@
                 <a:latin typeface="Poppins"/>
               </a:rPr>
               <a:t>Maestría en Administración de la Educación · Escuela de Posgrado UNA Puno · 2026</a:t>
+            </a:r>
+          </a:p>
+        </p:txBody>
+      </p:sp>
+      <p:sp>
+        <p:nvSpPr>
+          <p:cNvPr id="28" name="Oval 27"/>
+          <p:cNvSpPr/>
+          <p:nvPr/>
+        </p:nvSpPr>
+        <p:spPr>
+          <a:xfrm>
+            <a:off x="4178808" y="4681728"/>
+            <a:ext cx="1060704" cy="1060704"/>
+          </a:xfrm>
+          <a:prstGeom prst="ellipse">
+            <a:avLst/>
+          </a:prstGeom>
+          <a:solidFill>
+            <a:srgbClr val="E0A526"/>
+          </a:solidFill>
+          <a:ln>
+            <a:noFill/>
+          </a:ln>
+          <a:effectLst/>
+        </p:spPr>
+        <p:style>
+          <a:lnRef idx="1">
+            <a:schemeClr val="accent1"/>
+          </a:lnRef>
+          <a:fillRef idx="3">
+            <a:schemeClr val="accent1"/>
+          </a:fillRef>
+          <a:effectRef idx="2">
+            <a:schemeClr val="accent1"/>
+          </a:effectRef>
+          <a:fontRef idx="minor">
+            <a:schemeClr val="lt1"/>
+          </a:fontRef>
+        </p:style>
+        <p:txBody>
+          <a:bodyPr rtlCol="0" anchor="ctr"/>
+          <a:lstStyle/>
+          <a:p>
+            <a:pPr algn="ctr"/>
+          </a:p>
+        </p:txBody>
+      </p:sp>
+      <p:pic>
+        <p:nvPicPr>
+          <p:cNvPr id="29" name="Picture 28" descr="pres_round.png"/>
+          <p:cNvPicPr>
+            <a:picLocks noChangeAspect="1"/>
+          </p:cNvPicPr>
+          <p:nvPr/>
+        </p:nvPicPr>
+        <p:blipFill>
+          <a:blip r:embed="rId6"/>
+          <a:stretch>
+            <a:fillRect/>
+          </a:stretch>
+        </p:blipFill>
+        <p:spPr>
+          <a:xfrm>
+            <a:off x="4224528" y="4727448"/>
+            <a:ext cx="969264" cy="969264"/>
+          </a:xfrm>
+          <a:prstGeom prst="rect">
+            <a:avLst/>
+          </a:prstGeom>
+        </p:spPr>
+      </p:pic>
+      <p:sp>
+        <p:nvSpPr>
+          <p:cNvPr id="30" name="Rounded Rectangle 29"/>
+          <p:cNvSpPr/>
+          <p:nvPr/>
+        </p:nvSpPr>
+        <p:spPr>
+          <a:xfrm>
+            <a:off x="3767328" y="5797296"/>
+            <a:ext cx="1883664" cy="301752"/>
+          </a:xfrm>
+          <a:prstGeom prst="roundRect">
+            <a:avLst>
+              <a:gd name="adj" fmla="val 50000"/>
+            </a:avLst>
+          </a:prstGeom>
+          <a:solidFill>
+            <a:srgbClr val="E0A526"/>
+          </a:solidFill>
+          <a:ln>
+            <a:noFill/>
+          </a:ln>
+          <a:effectLst/>
+        </p:spPr>
+        <p:style>
+          <a:lnRef idx="1">
+            <a:schemeClr val="accent1"/>
+          </a:lnRef>
+          <a:fillRef idx="3">
+            <a:schemeClr val="accent1"/>
+          </a:fillRef>
+          <a:effectRef idx="2">
+            <a:schemeClr val="accent1"/>
+          </a:effectRef>
+          <a:fontRef idx="minor">
+            <a:schemeClr val="lt1"/>
+          </a:fontRef>
+        </p:style>
+        <p:txBody>
+          <a:bodyPr rtlCol="0" anchor="ctr"/>
+          <a:lstStyle/>
+          <a:p>
+            <a:pPr algn="ctr"/>
+          </a:p>
+        </p:txBody>
+      </p:sp>
+      <p:sp>
+        <p:nvSpPr>
+          <p:cNvPr id="31" name="TextBox 30"/>
+          <p:cNvSpPr txBox="1"/>
+          <p:nvPr/>
+        </p:nvSpPr>
+        <p:spPr>
+          <a:xfrm>
+            <a:off x="3767328" y="5797296"/>
+            <a:ext cx="1883664" cy="301752"/>
+          </a:xfrm>
+          <a:prstGeom prst="rect">
+            <a:avLst/>
+          </a:prstGeom>
+          <a:noFill/>
+        </p:spPr>
+        <p:txBody>
+          <a:bodyPr wrap="square" anchor="ctr" lIns="0" rIns="0" tIns="0" bIns="0">
+            <a:spAutoFit/>
+          </a:bodyPr>
+          <a:lstStyle/>
+          <a:p>
+            <a:pPr algn="ctr"/>
+            <a:r>
+              <a:rPr sz="1000" b="1">
+                <a:solidFill>
+                  <a:srgbClr val="0F2A44"/>
+                </a:solidFill>
+                <a:latin typeface="Poppins"/>
+              </a:rPr>
+              <a:t>Presidente · Grupo Natalio</a:t>
+            </a:r>
+          </a:p>
+        </p:txBody>
+      </p:sp>
+      <p:sp>
+        <p:nvSpPr>
+          <p:cNvPr id="32" name="Rounded Rectangle 31"/>
+          <p:cNvSpPr/>
+          <p:nvPr/>
+        </p:nvSpPr>
+        <p:spPr>
+          <a:xfrm>
+            <a:off x="6080760" y="4681728"/>
+            <a:ext cx="1005840" cy="1060704"/>
+          </a:xfrm>
+          <a:prstGeom prst="roundRect">
+            <a:avLst>
+              <a:gd name="adj" fmla="val 10000"/>
+            </a:avLst>
+          </a:prstGeom>
+          <a:solidFill>
+            <a:srgbClr val="FFFFFF"/>
+          </a:solidFill>
+          <a:ln w="15875">
+            <a:solidFill>
+              <a:srgbClr val="E0A526"/>
+            </a:solidFill>
+          </a:ln>
+          <a:effectLst/>
+        </p:spPr>
+        <p:style>
+          <a:lnRef idx="1">
+            <a:schemeClr val="accent1"/>
+          </a:lnRef>
+          <a:fillRef idx="3">
+            <a:schemeClr val="accent1"/>
+          </a:fillRef>
+          <a:effectRef idx="2">
+            <a:schemeClr val="accent1"/>
+          </a:effectRef>
+          <a:fontRef idx="minor">
+            <a:schemeClr val="lt1"/>
+          </a:fontRef>
+        </p:style>
+        <p:txBody>
+          <a:bodyPr rtlCol="0" anchor="ctr"/>
+          <a:lstStyle/>
+          <a:p>
+            <a:pPr algn="ctr"/>
+          </a:p>
+        </p:txBody>
+      </p:sp>
+      <p:pic>
+        <p:nvPicPr>
+          <p:cNvPr id="33" name="Picture 32" descr="futbolista_crop.png"/>
+          <p:cNvPicPr>
+            <a:picLocks noChangeAspect="1"/>
+          </p:cNvPicPr>
+          <p:nvPr/>
+        </p:nvPicPr>
+        <p:blipFill>
+          <a:blip r:embed="rId7"/>
+          <a:stretch>
+            <a:fillRect/>
+          </a:stretch>
+        </p:blipFill>
+        <p:spPr>
+          <a:xfrm>
+            <a:off x="6172200" y="4718304"/>
+            <a:ext cx="822960" cy="1014984"/>
+          </a:xfrm>
+          <a:prstGeom prst="rect">
+            <a:avLst/>
+          </a:prstGeom>
+        </p:spPr>
+      </p:pic>
+      <p:sp>
+        <p:nvSpPr>
+          <p:cNvPr id="34" name="Rounded Rectangle 33"/>
+          <p:cNvSpPr/>
+          <p:nvPr/>
+        </p:nvSpPr>
+        <p:spPr>
+          <a:xfrm>
+            <a:off x="5760720" y="5797296"/>
+            <a:ext cx="1645920" cy="301752"/>
+          </a:xfrm>
+          <a:prstGeom prst="roundRect">
+            <a:avLst>
+              <a:gd name="adj" fmla="val 50000"/>
+            </a:avLst>
+          </a:prstGeom>
+          <a:solidFill>
+            <a:srgbClr val="E0A526"/>
+          </a:solidFill>
+          <a:ln>
+            <a:noFill/>
+          </a:ln>
+          <a:effectLst/>
+        </p:spPr>
+        <p:style>
+          <a:lnRef idx="1">
+            <a:schemeClr val="accent1"/>
+          </a:lnRef>
+          <a:fillRef idx="3">
+            <a:schemeClr val="accent1"/>
+          </a:fillRef>
+          <a:effectRef idx="2">
+            <a:schemeClr val="accent1"/>
+          </a:effectRef>
+          <a:fontRef idx="minor">
+            <a:schemeClr val="lt1"/>
+          </a:fontRef>
+        </p:style>
+        <p:txBody>
+          <a:bodyPr rtlCol="0" anchor="ctr"/>
+          <a:lstStyle/>
+          <a:p>
+            <a:pPr algn="ctr"/>
+          </a:p>
+        </p:txBody>
+      </p:sp>
+      <p:sp>
+        <p:nvSpPr>
+          <p:cNvPr id="35" name="TextBox 34"/>
+          <p:cNvSpPr txBox="1"/>
+          <p:nvPr/>
+        </p:nvSpPr>
+        <p:spPr>
+          <a:xfrm>
+            <a:off x="5760720" y="5797296"/>
+            <a:ext cx="1645920" cy="301752"/>
+          </a:xfrm>
+          <a:prstGeom prst="rect">
+            <a:avLst/>
+          </a:prstGeom>
+          <a:noFill/>
+        </p:spPr>
+        <p:txBody>
+          <a:bodyPr wrap="square" anchor="ctr" lIns="0" rIns="0" tIns="0" bIns="0">
+            <a:spAutoFit/>
+          </a:bodyPr>
+          <a:lstStyle/>
+          <a:p>
+            <a:pPr algn="ctr"/>
+            <a:r>
+              <a:rPr sz="1000" b="1">
+                <a:solidFill>
+                  <a:srgbClr val="0F2A44"/>
+                </a:solidFill>
+                <a:latin typeface="Poppins"/>
+              </a:rPr>
+              <a:t>Carrillo · artículo 10</a:t>
             </a:r>
           </a:p>
         </p:txBody>

</xml_diff>